<commit_message>
update financial service scenario
fs scenario simulation
</commit_message>
<xml_diff>
--- a/Ad_Auction_Simulator_Dashboard.pptx
+++ b/Ad_Auction_Simulator_Dashboard.pptx
@@ -16,6 +16,7 @@
     <p:sldId id="264" r:id="rId15"/>
     <p:sldId id="265" r:id="rId16"/>
     <p:sldId id="266" r:id="rId17"/>
+    <p:sldId id="267" r:id="rId18"/>
   </p:sldIdLst>
   <p:sldSz cx="12191695" cy="6858000" type="screen4x3"/>
   <p:notesSz cx="6858000" cy="9144000"/>
@@ -3521,7 +3522,7 @@
               </a:defRPr>
             </a:pPr>
             <a:r>
-              <a:t>Quality Feedback</a:t>
+              <a:t>Thompson Sampling</a:t>
             </a:r>
           </a:p>
         </p:txBody>
@@ -3598,7 +3599,7 @@
               </a:defRPr>
             </a:pPr>
             <a:r>
-              <a:t>Thompson Sampling</a:t>
+              <a:t>Latency-Aware Cascade</a:t>
             </a:r>
           </a:p>
         </p:txBody>
@@ -3675,7 +3676,7 @@
               </a:defRPr>
             </a:pPr>
             <a:r>
-              <a:t>Latency-Aware Cascade</a:t>
+              <a:t>Model Strategy</a:t>
             </a:r>
           </a:p>
         </p:txBody>
@@ -3752,7 +3753,7 @@
               </a:defRPr>
             </a:pPr>
             <a:r>
-              <a:t>Model Strategy</a:t>
+              <a:t>Finance Scenario</a:t>
             </a:r>
           </a:p>
         </p:txBody>
@@ -6291,6 +6292,14 @@
 <file path=ppt/slides/slide11.xml><?xml version="1.0" encoding="utf-8"?>
 <p:sld xmlns:a="http://schemas.openxmlformats.org/drawingml/2006/main" xmlns:p="http://schemas.openxmlformats.org/presentationml/2006/main" xmlns:r="http://schemas.openxmlformats.org/officeDocument/2006/relationships">
   <p:cSld>
+    <p:bg>
+      <p:bgPr>
+        <a:solidFill>
+          <a:srgbClr val="F8FAFC"/>
+        </a:solidFill>
+        <a:effectLst/>
+      </p:bgPr>
+    </p:bg>
     <p:spTree>
       <p:nvGrpSpPr>
         <p:cNvPr id="1" name=""/>
@@ -6300,6 +6309,3124 @@
       <p:grpSpPr/>
       <p:sp>
         <p:nvSpPr>
+          <p:cNvPr id="2" name="TextBox 1"/>
+          <p:cNvSpPr txBox="1"/>
+          <p:nvPr/>
+        </p:nvSpPr>
+        <p:spPr>
+          <a:xfrm>
+            <a:off x="548640" y="365760"/>
+            <a:ext cx="9144000" cy="457200"/>
+          </a:xfrm>
+          <a:prstGeom prst="rect">
+            <a:avLst/>
+          </a:prstGeom>
+          <a:noFill/>
+        </p:spPr>
+        <p:txBody>
+          <a:bodyPr wrap="square"/>
+          <a:lstStyle/>
+          <a:p>
+            <a:pPr algn="l">
+              <a:defRPr sz="2800" b="1">
+                <a:solidFill>
+                  <a:srgbClr val="111827"/>
+                </a:solidFill>
+                <a:latin typeface="Calibri"/>
+              </a:defRPr>
+            </a:pPr>
+            <a:r>
+              <a:t>Financial Services Scenario</a:t>
+            </a:r>
+          </a:p>
+        </p:txBody>
+      </p:sp>
+      <p:sp>
+        <p:nvSpPr>
+          <p:cNvPr id="3" name="TextBox 2"/>
+          <p:cNvSpPr txBox="1"/>
+          <p:nvPr/>
+        </p:nvSpPr>
+        <p:spPr>
+          <a:xfrm>
+            <a:off x="548640" y="822960"/>
+            <a:ext cx="9144000" cy="274320"/>
+          </a:xfrm>
+          <a:prstGeom prst="rect">
+            <a:avLst/>
+          </a:prstGeom>
+          <a:noFill/>
+        </p:spPr>
+        <p:txBody>
+          <a:bodyPr wrap="square"/>
+          <a:lstStyle/>
+          <a:p>
+            <a:pPr algn="l">
+              <a:defRPr sz="1200" b="0">
+                <a:solidFill>
+                  <a:srgbClr val="6B7280"/>
+                </a:solidFill>
+                <a:latin typeface="Calibri"/>
+              </a:defRPr>
+            </a:pPr>
+            <a:r>
+              <a:t>30-day simulation comparing 6 recommender algorithms for high-stakes financial advertising</a:t>
+            </a:r>
+          </a:p>
+        </p:txBody>
+      </p:sp>
+      <p:sp>
+        <p:nvSpPr>
+          <p:cNvPr id="4" name="Rectangle 3"/>
+          <p:cNvSpPr/>
+          <p:nvPr/>
+        </p:nvSpPr>
+        <p:spPr>
+          <a:xfrm>
+            <a:off x="548640" y="1371600"/>
+            <a:ext cx="6583680" cy="2926080"/>
+          </a:xfrm>
+          <a:prstGeom prst="rect">
+            <a:avLst/>
+          </a:prstGeom>
+          <a:solidFill>
+            <a:srgbClr val="FFFFFF"/>
+          </a:solidFill>
+          <a:ln>
+            <a:noFill/>
+          </a:ln>
+        </p:spPr>
+        <p:style>
+          <a:lnRef idx="1">
+            <a:schemeClr val="accent1"/>
+          </a:lnRef>
+          <a:fillRef idx="3">
+            <a:schemeClr val="accent1"/>
+          </a:fillRef>
+          <a:effectRef idx="2">
+            <a:schemeClr val="accent1"/>
+          </a:effectRef>
+          <a:fontRef idx="minor">
+            <a:schemeClr val="lt1"/>
+          </a:fontRef>
+        </p:style>
+        <p:txBody>
+          <a:bodyPr rtlCol="0" anchor="ctr"/>
+          <a:lstStyle/>
+          <a:p>
+            <a:pPr algn="ctr"/>
+          </a:p>
+        </p:txBody>
+      </p:sp>
+      <p:sp>
+        <p:nvSpPr>
+          <p:cNvPr id="5" name="TextBox 4"/>
+          <p:cNvSpPr txBox="1"/>
+          <p:nvPr/>
+        </p:nvSpPr>
+        <p:spPr>
+          <a:xfrm>
+            <a:off x="731520" y="1463040"/>
+            <a:ext cx="6217920" cy="274320"/>
+          </a:xfrm>
+          <a:prstGeom prst="rect">
+            <a:avLst/>
+          </a:prstGeom>
+          <a:noFill/>
+        </p:spPr>
+        <p:txBody>
+          <a:bodyPr wrap="square"/>
+          <a:lstStyle/>
+          <a:p>
+            <a:pPr algn="l">
+              <a:defRPr sz="1200" b="1">
+                <a:solidFill>
+                  <a:srgbClr val="111827"/>
+                </a:solidFill>
+                <a:latin typeface="Calibri"/>
+              </a:defRPr>
+            </a:pPr>
+            <a:r>
+              <a:t>Algorithm Rankings (Credit Cards Sub-Vertical)</a:t>
+            </a:r>
+          </a:p>
+        </p:txBody>
+      </p:sp>
+      <p:sp>
+        <p:nvSpPr>
+          <p:cNvPr id="6" name="Rectangle 5"/>
+          <p:cNvSpPr/>
+          <p:nvPr/>
+        </p:nvSpPr>
+        <p:spPr>
+          <a:xfrm>
+            <a:off x="640080" y="1783080"/>
+            <a:ext cx="6400800" cy="256032"/>
+          </a:xfrm>
+          <a:prstGeom prst="rect">
+            <a:avLst/>
+          </a:prstGeom>
+          <a:solidFill>
+            <a:srgbClr val="DBEAFE"/>
+          </a:solidFill>
+          <a:ln>
+            <a:noFill/>
+          </a:ln>
+        </p:spPr>
+        <p:style>
+          <a:lnRef idx="1">
+            <a:schemeClr val="accent1"/>
+          </a:lnRef>
+          <a:fillRef idx="3">
+            <a:schemeClr val="accent1"/>
+          </a:fillRef>
+          <a:effectRef idx="2">
+            <a:schemeClr val="accent1"/>
+          </a:effectRef>
+          <a:fontRef idx="minor">
+            <a:schemeClr val="lt1"/>
+          </a:fontRef>
+        </p:style>
+        <p:txBody>
+          <a:bodyPr rtlCol="0" anchor="ctr"/>
+          <a:lstStyle/>
+          <a:p>
+            <a:pPr algn="ctr"/>
+          </a:p>
+        </p:txBody>
+      </p:sp>
+      <p:sp>
+        <p:nvSpPr>
+          <p:cNvPr id="7" name="TextBox 6"/>
+          <p:cNvSpPr txBox="1"/>
+          <p:nvPr/>
+        </p:nvSpPr>
+        <p:spPr>
+          <a:xfrm>
+            <a:off x="685800" y="1801368"/>
+            <a:ext cx="1051560" cy="256032"/>
+          </a:xfrm>
+          <a:prstGeom prst="rect">
+            <a:avLst/>
+          </a:prstGeom>
+          <a:noFill/>
+        </p:spPr>
+        <p:txBody>
+          <a:bodyPr wrap="square"/>
+          <a:lstStyle/>
+          <a:p>
+            <a:pPr algn="l">
+              <a:defRPr sz="800" b="1">
+                <a:solidFill>
+                  <a:srgbClr val="1D4ED8"/>
+                </a:solidFill>
+                <a:latin typeface="Calibri"/>
+              </a:defRPr>
+            </a:pPr>
+            <a:r>
+              <a:t>Algorithm</a:t>
+            </a:r>
+          </a:p>
+        </p:txBody>
+      </p:sp>
+      <p:sp>
+        <p:nvSpPr>
+          <p:cNvPr id="8" name="TextBox 7"/>
+          <p:cNvSpPr txBox="1"/>
+          <p:nvPr/>
+        </p:nvSpPr>
+        <p:spPr>
+          <a:xfrm>
+            <a:off x="1737360" y="1801368"/>
+            <a:ext cx="1051560" cy="256032"/>
+          </a:xfrm>
+          <a:prstGeom prst="rect">
+            <a:avLst/>
+          </a:prstGeom>
+          <a:noFill/>
+        </p:spPr>
+        <p:txBody>
+          <a:bodyPr wrap="square"/>
+          <a:lstStyle/>
+          <a:p>
+            <a:pPr algn="l">
+              <a:defRPr sz="800" b="1">
+                <a:solidFill>
+                  <a:srgbClr val="1D4ED8"/>
+                </a:solidFill>
+                <a:latin typeface="Calibri"/>
+              </a:defRPr>
+            </a:pPr>
+            <a:r>
+              <a:t>Revenue</a:t>
+            </a:r>
+          </a:p>
+        </p:txBody>
+      </p:sp>
+      <p:sp>
+        <p:nvSpPr>
+          <p:cNvPr id="9" name="TextBox 8"/>
+          <p:cNvSpPr txBox="1"/>
+          <p:nvPr/>
+        </p:nvSpPr>
+        <p:spPr>
+          <a:xfrm>
+            <a:off x="2788920" y="1801368"/>
+            <a:ext cx="1051560" cy="256032"/>
+          </a:xfrm>
+          <a:prstGeom prst="rect">
+            <a:avLst/>
+          </a:prstGeom>
+          <a:noFill/>
+        </p:spPr>
+        <p:txBody>
+          <a:bodyPr wrap="square"/>
+          <a:lstStyle/>
+          <a:p>
+            <a:pPr algn="l">
+              <a:defRPr sz="800" b="1">
+                <a:solidFill>
+                  <a:srgbClr val="1D4ED8"/>
+                </a:solidFill>
+                <a:latin typeface="Calibri"/>
+              </a:defRPr>
+            </a:pPr>
+            <a:r>
+              <a:t>Trust</a:t>
+            </a:r>
+          </a:p>
+        </p:txBody>
+      </p:sp>
+      <p:sp>
+        <p:nvSpPr>
+          <p:cNvPr id="10" name="TextBox 9"/>
+          <p:cNvSpPr txBox="1"/>
+          <p:nvPr/>
+        </p:nvSpPr>
+        <p:spPr>
+          <a:xfrm>
+            <a:off x="3840480" y="1801368"/>
+            <a:ext cx="1051560" cy="256032"/>
+          </a:xfrm>
+          <a:prstGeom prst="rect">
+            <a:avLst/>
+          </a:prstGeom>
+          <a:noFill/>
+        </p:spPr>
+        <p:txBody>
+          <a:bodyPr wrap="square"/>
+          <a:lstStyle/>
+          <a:p>
+            <a:pPr algn="l">
+              <a:defRPr sz="800" b="1">
+                <a:solidFill>
+                  <a:srgbClr val="1D4ED8"/>
+                </a:solidFill>
+                <a:latin typeface="Calibri"/>
+              </a:defRPr>
+            </a:pPr>
+            <a:r>
+              <a:t>Risk</a:t>
+            </a:r>
+          </a:p>
+        </p:txBody>
+      </p:sp>
+      <p:sp>
+        <p:nvSpPr>
+          <p:cNvPr id="11" name="TextBox 10"/>
+          <p:cNvSpPr txBox="1"/>
+          <p:nvPr/>
+        </p:nvSpPr>
+        <p:spPr>
+          <a:xfrm>
+            <a:off x="4892040" y="1801368"/>
+            <a:ext cx="1051560" cy="256032"/>
+          </a:xfrm>
+          <a:prstGeom prst="rect">
+            <a:avLst/>
+          </a:prstGeom>
+          <a:noFill/>
+        </p:spPr>
+        <p:txBody>
+          <a:bodyPr wrap="square"/>
+          <a:lstStyle/>
+          <a:p>
+            <a:pPr algn="l">
+              <a:defRPr sz="800" b="1">
+                <a:solidFill>
+                  <a:srgbClr val="1D4ED8"/>
+                </a:solidFill>
+                <a:latin typeface="Calibri"/>
+              </a:defRPr>
+            </a:pPr>
+            <a:r>
+              <a:t>CPA</a:t>
+            </a:r>
+          </a:p>
+        </p:txBody>
+      </p:sp>
+      <p:sp>
+        <p:nvSpPr>
+          <p:cNvPr id="12" name="TextBox 11"/>
+          <p:cNvSpPr txBox="1"/>
+          <p:nvPr/>
+        </p:nvSpPr>
+        <p:spPr>
+          <a:xfrm>
+            <a:off x="5943600" y="1801368"/>
+            <a:ext cx="1051560" cy="256032"/>
+          </a:xfrm>
+          <a:prstGeom prst="rect">
+            <a:avLst/>
+          </a:prstGeom>
+          <a:noFill/>
+        </p:spPr>
+        <p:txBody>
+          <a:bodyPr wrap="square"/>
+          <a:lstStyle/>
+          <a:p>
+            <a:pPr algn="l">
+              <a:defRPr sz="800" b="1">
+                <a:solidFill>
+                  <a:srgbClr val="1D4ED8"/>
+                </a:solidFill>
+                <a:latin typeface="Calibri"/>
+              </a:defRPr>
+            </a:pPr>
+            <a:r>
+              <a:t>Composite</a:t>
+            </a:r>
+          </a:p>
+        </p:txBody>
+      </p:sp>
+      <p:sp>
+        <p:nvSpPr>
+          <p:cNvPr id="13" name="TextBox 12"/>
+          <p:cNvSpPr txBox="1"/>
+          <p:nvPr/>
+        </p:nvSpPr>
+        <p:spPr>
+          <a:xfrm>
+            <a:off x="685800" y="2057400"/>
+            <a:ext cx="1051560" cy="256032"/>
+          </a:xfrm>
+          <a:prstGeom prst="rect">
+            <a:avLst/>
+          </a:prstGeom>
+          <a:noFill/>
+        </p:spPr>
+        <p:txBody>
+          <a:bodyPr wrap="square"/>
+          <a:lstStyle/>
+          <a:p>
+            <a:pPr algn="l">
+              <a:defRPr sz="900" b="0">
+                <a:solidFill>
+                  <a:srgbClr val="374151"/>
+                </a:solidFill>
+                <a:latin typeface="Calibri"/>
+              </a:defRPr>
+            </a:pPr>
+            <a:r>
+              <a:t>Risk-Adjusted Ranker</a:t>
+            </a:r>
+          </a:p>
+        </p:txBody>
+      </p:sp>
+      <p:sp>
+        <p:nvSpPr>
+          <p:cNvPr id="14" name="TextBox 13"/>
+          <p:cNvSpPr txBox="1"/>
+          <p:nvPr/>
+        </p:nvSpPr>
+        <p:spPr>
+          <a:xfrm>
+            <a:off x="1737360" y="2057400"/>
+            <a:ext cx="1051560" cy="256032"/>
+          </a:xfrm>
+          <a:prstGeom prst="rect">
+            <a:avLst/>
+          </a:prstGeom>
+          <a:noFill/>
+        </p:spPr>
+        <p:txBody>
+          <a:bodyPr wrap="square"/>
+          <a:lstStyle/>
+          <a:p>
+            <a:pPr algn="l">
+              <a:defRPr sz="900" b="0">
+                <a:solidFill>
+                  <a:srgbClr val="374151"/>
+                </a:solidFill>
+                <a:latin typeface="Calibri"/>
+              </a:defRPr>
+            </a:pPr>
+            <a:r>
+              <a:t>$48.2K</a:t>
+            </a:r>
+          </a:p>
+        </p:txBody>
+      </p:sp>
+      <p:sp>
+        <p:nvSpPr>
+          <p:cNvPr id="15" name="TextBox 14"/>
+          <p:cNvSpPr txBox="1"/>
+          <p:nvPr/>
+        </p:nvSpPr>
+        <p:spPr>
+          <a:xfrm>
+            <a:off x="2788920" y="2057400"/>
+            <a:ext cx="1051560" cy="256032"/>
+          </a:xfrm>
+          <a:prstGeom prst="rect">
+            <a:avLst/>
+          </a:prstGeom>
+          <a:noFill/>
+        </p:spPr>
+        <p:txBody>
+          <a:bodyPr wrap="square"/>
+          <a:lstStyle/>
+          <a:p>
+            <a:pPr algn="l">
+              <a:defRPr sz="900" b="0">
+                <a:solidFill>
+                  <a:srgbClr val="374151"/>
+                </a:solidFill>
+                <a:latin typeface="Calibri"/>
+              </a:defRPr>
+            </a:pPr>
+            <a:r>
+              <a:t>87%</a:t>
+            </a:r>
+          </a:p>
+        </p:txBody>
+      </p:sp>
+      <p:sp>
+        <p:nvSpPr>
+          <p:cNvPr id="16" name="TextBox 15"/>
+          <p:cNvSpPr txBox="1"/>
+          <p:nvPr/>
+        </p:nvSpPr>
+        <p:spPr>
+          <a:xfrm>
+            <a:off x="3840480" y="2057400"/>
+            <a:ext cx="1051560" cy="256032"/>
+          </a:xfrm>
+          <a:prstGeom prst="rect">
+            <a:avLst/>
+          </a:prstGeom>
+          <a:noFill/>
+        </p:spPr>
+        <p:txBody>
+          <a:bodyPr wrap="square"/>
+          <a:lstStyle/>
+          <a:p>
+            <a:pPr algn="l">
+              <a:defRPr sz="900" b="0">
+                <a:solidFill>
+                  <a:srgbClr val="374151"/>
+                </a:solidFill>
+                <a:latin typeface="Calibri"/>
+              </a:defRPr>
+            </a:pPr>
+            <a:r>
+              <a:t>3</a:t>
+            </a:r>
+          </a:p>
+        </p:txBody>
+      </p:sp>
+      <p:sp>
+        <p:nvSpPr>
+          <p:cNvPr id="17" name="TextBox 16"/>
+          <p:cNvSpPr txBox="1"/>
+          <p:nvPr/>
+        </p:nvSpPr>
+        <p:spPr>
+          <a:xfrm>
+            <a:off x="4892040" y="2057400"/>
+            <a:ext cx="1051560" cy="256032"/>
+          </a:xfrm>
+          <a:prstGeom prst="rect">
+            <a:avLst/>
+          </a:prstGeom>
+          <a:noFill/>
+        </p:spPr>
+        <p:txBody>
+          <a:bodyPr wrap="square"/>
+          <a:lstStyle/>
+          <a:p>
+            <a:pPr algn="l">
+              <a:defRPr sz="900" b="0">
+                <a:solidFill>
+                  <a:srgbClr val="374151"/>
+                </a:solidFill>
+                <a:latin typeface="Calibri"/>
+              </a:defRPr>
+            </a:pPr>
+            <a:r>
+              <a:t>$42</a:t>
+            </a:r>
+          </a:p>
+        </p:txBody>
+      </p:sp>
+      <p:sp>
+        <p:nvSpPr>
+          <p:cNvPr id="18" name="TextBox 17"/>
+          <p:cNvSpPr txBox="1"/>
+          <p:nvPr/>
+        </p:nvSpPr>
+        <p:spPr>
+          <a:xfrm>
+            <a:off x="5943600" y="2057400"/>
+            <a:ext cx="1051560" cy="256032"/>
+          </a:xfrm>
+          <a:prstGeom prst="rect">
+            <a:avLst/>
+          </a:prstGeom>
+          <a:noFill/>
+        </p:spPr>
+        <p:txBody>
+          <a:bodyPr wrap="square"/>
+          <a:lstStyle/>
+          <a:p>
+            <a:pPr algn="l">
+              <a:defRPr sz="900" b="0">
+                <a:solidFill>
+                  <a:srgbClr val="374151"/>
+                </a:solidFill>
+                <a:latin typeface="Calibri"/>
+              </a:defRPr>
+            </a:pPr>
+            <a:r>
+              <a:t>82.4%</a:t>
+            </a:r>
+          </a:p>
+        </p:txBody>
+      </p:sp>
+      <p:sp>
+        <p:nvSpPr>
+          <p:cNvPr id="19" name="Rectangle 18"/>
+          <p:cNvSpPr/>
+          <p:nvPr/>
+        </p:nvSpPr>
+        <p:spPr>
+          <a:xfrm>
+            <a:off x="685800" y="2286000"/>
+            <a:ext cx="6309360" cy="4572"/>
+          </a:xfrm>
+          <a:prstGeom prst="rect">
+            <a:avLst/>
+          </a:prstGeom>
+          <a:solidFill>
+            <a:srgbClr val="F3F4F6"/>
+          </a:solidFill>
+          <a:ln>
+            <a:noFill/>
+          </a:ln>
+        </p:spPr>
+        <p:style>
+          <a:lnRef idx="1">
+            <a:schemeClr val="accent1"/>
+          </a:lnRef>
+          <a:fillRef idx="3">
+            <a:schemeClr val="accent1"/>
+          </a:fillRef>
+          <a:effectRef idx="2">
+            <a:schemeClr val="accent1"/>
+          </a:effectRef>
+          <a:fontRef idx="minor">
+            <a:schemeClr val="lt1"/>
+          </a:fontRef>
+        </p:style>
+        <p:txBody>
+          <a:bodyPr rtlCol="0" anchor="ctr"/>
+          <a:lstStyle/>
+          <a:p>
+            <a:pPr algn="ctr"/>
+          </a:p>
+        </p:txBody>
+      </p:sp>
+      <p:sp>
+        <p:nvSpPr>
+          <p:cNvPr id="20" name="TextBox 19"/>
+          <p:cNvSpPr txBox="1"/>
+          <p:nvPr/>
+        </p:nvSpPr>
+        <p:spPr>
+          <a:xfrm>
+            <a:off x="685800" y="2313432"/>
+            <a:ext cx="1051560" cy="256032"/>
+          </a:xfrm>
+          <a:prstGeom prst="rect">
+            <a:avLst/>
+          </a:prstGeom>
+          <a:noFill/>
+        </p:spPr>
+        <p:txBody>
+          <a:bodyPr wrap="square"/>
+          <a:lstStyle/>
+          <a:p>
+            <a:pPr algn="l">
+              <a:defRPr sz="900" b="0">
+                <a:solidFill>
+                  <a:srgbClr val="374151"/>
+                </a:solidFill>
+                <a:latin typeface="Calibri"/>
+              </a:defRPr>
+            </a:pPr>
+            <a:r>
+              <a:t>Hybrid Ensemble</a:t>
+            </a:r>
+          </a:p>
+        </p:txBody>
+      </p:sp>
+      <p:sp>
+        <p:nvSpPr>
+          <p:cNvPr id="21" name="TextBox 20"/>
+          <p:cNvSpPr txBox="1"/>
+          <p:nvPr/>
+        </p:nvSpPr>
+        <p:spPr>
+          <a:xfrm>
+            <a:off x="1737360" y="2313432"/>
+            <a:ext cx="1051560" cy="256032"/>
+          </a:xfrm>
+          <a:prstGeom prst="rect">
+            <a:avLst/>
+          </a:prstGeom>
+          <a:noFill/>
+        </p:spPr>
+        <p:txBody>
+          <a:bodyPr wrap="square"/>
+          <a:lstStyle/>
+          <a:p>
+            <a:pPr algn="l">
+              <a:defRPr sz="900" b="0">
+                <a:solidFill>
+                  <a:srgbClr val="374151"/>
+                </a:solidFill>
+                <a:latin typeface="Calibri"/>
+              </a:defRPr>
+            </a:pPr>
+            <a:r>
+              <a:t>$51.0K</a:t>
+            </a:r>
+          </a:p>
+        </p:txBody>
+      </p:sp>
+      <p:sp>
+        <p:nvSpPr>
+          <p:cNvPr id="22" name="TextBox 21"/>
+          <p:cNvSpPr txBox="1"/>
+          <p:nvPr/>
+        </p:nvSpPr>
+        <p:spPr>
+          <a:xfrm>
+            <a:off x="2788920" y="2313432"/>
+            <a:ext cx="1051560" cy="256032"/>
+          </a:xfrm>
+          <a:prstGeom prst="rect">
+            <a:avLst/>
+          </a:prstGeom>
+          <a:noFill/>
+        </p:spPr>
+        <p:txBody>
+          <a:bodyPr wrap="square"/>
+          <a:lstStyle/>
+          <a:p>
+            <a:pPr algn="l">
+              <a:defRPr sz="900" b="0">
+                <a:solidFill>
+                  <a:srgbClr val="374151"/>
+                </a:solidFill>
+                <a:latin typeface="Calibri"/>
+              </a:defRPr>
+            </a:pPr>
+            <a:r>
+              <a:t>83%</a:t>
+            </a:r>
+          </a:p>
+        </p:txBody>
+      </p:sp>
+      <p:sp>
+        <p:nvSpPr>
+          <p:cNvPr id="23" name="TextBox 22"/>
+          <p:cNvSpPr txBox="1"/>
+          <p:nvPr/>
+        </p:nvSpPr>
+        <p:spPr>
+          <a:xfrm>
+            <a:off x="3840480" y="2313432"/>
+            <a:ext cx="1051560" cy="256032"/>
+          </a:xfrm>
+          <a:prstGeom prst="rect">
+            <a:avLst/>
+          </a:prstGeom>
+          <a:noFill/>
+        </p:spPr>
+        <p:txBody>
+          <a:bodyPr wrap="square"/>
+          <a:lstStyle/>
+          <a:p>
+            <a:pPr algn="l">
+              <a:defRPr sz="900" b="0">
+                <a:solidFill>
+                  <a:srgbClr val="374151"/>
+                </a:solidFill>
+                <a:latin typeface="Calibri"/>
+              </a:defRPr>
+            </a:pPr>
+            <a:r>
+              <a:t>5</a:t>
+            </a:r>
+          </a:p>
+        </p:txBody>
+      </p:sp>
+      <p:sp>
+        <p:nvSpPr>
+          <p:cNvPr id="24" name="TextBox 23"/>
+          <p:cNvSpPr txBox="1"/>
+          <p:nvPr/>
+        </p:nvSpPr>
+        <p:spPr>
+          <a:xfrm>
+            <a:off x="4892040" y="2313432"/>
+            <a:ext cx="1051560" cy="256032"/>
+          </a:xfrm>
+          <a:prstGeom prst="rect">
+            <a:avLst/>
+          </a:prstGeom>
+          <a:noFill/>
+        </p:spPr>
+        <p:txBody>
+          <a:bodyPr wrap="square"/>
+          <a:lstStyle/>
+          <a:p>
+            <a:pPr algn="l">
+              <a:defRPr sz="900" b="0">
+                <a:solidFill>
+                  <a:srgbClr val="374151"/>
+                </a:solidFill>
+                <a:latin typeface="Calibri"/>
+              </a:defRPr>
+            </a:pPr>
+            <a:r>
+              <a:t>$38</a:t>
+            </a:r>
+          </a:p>
+        </p:txBody>
+      </p:sp>
+      <p:sp>
+        <p:nvSpPr>
+          <p:cNvPr id="25" name="TextBox 24"/>
+          <p:cNvSpPr txBox="1"/>
+          <p:nvPr/>
+        </p:nvSpPr>
+        <p:spPr>
+          <a:xfrm>
+            <a:off x="5943600" y="2313432"/>
+            <a:ext cx="1051560" cy="256032"/>
+          </a:xfrm>
+          <a:prstGeom prst="rect">
+            <a:avLst/>
+          </a:prstGeom>
+          <a:noFill/>
+        </p:spPr>
+        <p:txBody>
+          <a:bodyPr wrap="square"/>
+          <a:lstStyle/>
+          <a:p>
+            <a:pPr algn="l">
+              <a:defRPr sz="900" b="0">
+                <a:solidFill>
+                  <a:srgbClr val="374151"/>
+                </a:solidFill>
+                <a:latin typeface="Calibri"/>
+              </a:defRPr>
+            </a:pPr>
+            <a:r>
+              <a:t>79.1%</a:t>
+            </a:r>
+          </a:p>
+        </p:txBody>
+      </p:sp>
+      <p:sp>
+        <p:nvSpPr>
+          <p:cNvPr id="26" name="Rectangle 25"/>
+          <p:cNvSpPr/>
+          <p:nvPr/>
+        </p:nvSpPr>
+        <p:spPr>
+          <a:xfrm>
+            <a:off x="685800" y="2542032"/>
+            <a:ext cx="6309360" cy="4572"/>
+          </a:xfrm>
+          <a:prstGeom prst="rect">
+            <a:avLst/>
+          </a:prstGeom>
+          <a:solidFill>
+            <a:srgbClr val="F3F4F6"/>
+          </a:solidFill>
+          <a:ln>
+            <a:noFill/>
+          </a:ln>
+        </p:spPr>
+        <p:style>
+          <a:lnRef idx="1">
+            <a:schemeClr val="accent1"/>
+          </a:lnRef>
+          <a:fillRef idx="3">
+            <a:schemeClr val="accent1"/>
+          </a:fillRef>
+          <a:effectRef idx="2">
+            <a:schemeClr val="accent1"/>
+          </a:effectRef>
+          <a:fontRef idx="minor">
+            <a:schemeClr val="lt1"/>
+          </a:fontRef>
+        </p:style>
+        <p:txBody>
+          <a:bodyPr rtlCol="0" anchor="ctr"/>
+          <a:lstStyle/>
+          <a:p>
+            <a:pPr algn="ctr"/>
+          </a:p>
+        </p:txBody>
+      </p:sp>
+      <p:sp>
+        <p:nvSpPr>
+          <p:cNvPr id="27" name="TextBox 26"/>
+          <p:cNvSpPr txBox="1"/>
+          <p:nvPr/>
+        </p:nvSpPr>
+        <p:spPr>
+          <a:xfrm>
+            <a:off x="685800" y="2569464"/>
+            <a:ext cx="1051560" cy="256032"/>
+          </a:xfrm>
+          <a:prstGeom prst="rect">
+            <a:avLst/>
+          </a:prstGeom>
+          <a:noFill/>
+        </p:spPr>
+        <p:txBody>
+          <a:bodyPr wrap="square"/>
+          <a:lstStyle/>
+          <a:p>
+            <a:pPr algn="l">
+              <a:defRPr sz="900" b="0">
+                <a:solidFill>
+                  <a:srgbClr val="374151"/>
+                </a:solidFill>
+                <a:latin typeface="Calibri"/>
+              </a:defRPr>
+            </a:pPr>
+            <a:r>
+              <a:t>GBDT Ranker</a:t>
+            </a:r>
+          </a:p>
+        </p:txBody>
+      </p:sp>
+      <p:sp>
+        <p:nvSpPr>
+          <p:cNvPr id="28" name="TextBox 27"/>
+          <p:cNvSpPr txBox="1"/>
+          <p:nvPr/>
+        </p:nvSpPr>
+        <p:spPr>
+          <a:xfrm>
+            <a:off x="1737360" y="2569464"/>
+            <a:ext cx="1051560" cy="256032"/>
+          </a:xfrm>
+          <a:prstGeom prst="rect">
+            <a:avLst/>
+          </a:prstGeom>
+          <a:noFill/>
+        </p:spPr>
+        <p:txBody>
+          <a:bodyPr wrap="square"/>
+          <a:lstStyle/>
+          <a:p>
+            <a:pPr algn="l">
+              <a:defRPr sz="900" b="0">
+                <a:solidFill>
+                  <a:srgbClr val="374151"/>
+                </a:solidFill>
+                <a:latin typeface="Calibri"/>
+              </a:defRPr>
+            </a:pPr>
+            <a:r>
+              <a:t>$45.8K</a:t>
+            </a:r>
+          </a:p>
+        </p:txBody>
+      </p:sp>
+      <p:sp>
+        <p:nvSpPr>
+          <p:cNvPr id="29" name="TextBox 28"/>
+          <p:cNvSpPr txBox="1"/>
+          <p:nvPr/>
+        </p:nvSpPr>
+        <p:spPr>
+          <a:xfrm>
+            <a:off x="2788920" y="2569464"/>
+            <a:ext cx="1051560" cy="256032"/>
+          </a:xfrm>
+          <a:prstGeom prst="rect">
+            <a:avLst/>
+          </a:prstGeom>
+          <a:noFill/>
+        </p:spPr>
+        <p:txBody>
+          <a:bodyPr wrap="square"/>
+          <a:lstStyle/>
+          <a:p>
+            <a:pPr algn="l">
+              <a:defRPr sz="900" b="0">
+                <a:solidFill>
+                  <a:srgbClr val="374151"/>
+                </a:solidFill>
+                <a:latin typeface="Calibri"/>
+              </a:defRPr>
+            </a:pPr>
+            <a:r>
+              <a:t>85%</a:t>
+            </a:r>
+          </a:p>
+        </p:txBody>
+      </p:sp>
+      <p:sp>
+        <p:nvSpPr>
+          <p:cNvPr id="30" name="TextBox 29"/>
+          <p:cNvSpPr txBox="1"/>
+          <p:nvPr/>
+        </p:nvSpPr>
+        <p:spPr>
+          <a:xfrm>
+            <a:off x="3840480" y="2569464"/>
+            <a:ext cx="1051560" cy="256032"/>
+          </a:xfrm>
+          <a:prstGeom prst="rect">
+            <a:avLst/>
+          </a:prstGeom>
+          <a:noFill/>
+        </p:spPr>
+        <p:txBody>
+          <a:bodyPr wrap="square"/>
+          <a:lstStyle/>
+          <a:p>
+            <a:pPr algn="l">
+              <a:defRPr sz="900" b="0">
+                <a:solidFill>
+                  <a:srgbClr val="374151"/>
+                </a:solidFill>
+                <a:latin typeface="Calibri"/>
+              </a:defRPr>
+            </a:pPr>
+            <a:r>
+              <a:t>4</a:t>
+            </a:r>
+          </a:p>
+        </p:txBody>
+      </p:sp>
+      <p:sp>
+        <p:nvSpPr>
+          <p:cNvPr id="31" name="TextBox 30"/>
+          <p:cNvSpPr txBox="1"/>
+          <p:nvPr/>
+        </p:nvSpPr>
+        <p:spPr>
+          <a:xfrm>
+            <a:off x="4892040" y="2569464"/>
+            <a:ext cx="1051560" cy="256032"/>
+          </a:xfrm>
+          <a:prstGeom prst="rect">
+            <a:avLst/>
+          </a:prstGeom>
+          <a:noFill/>
+        </p:spPr>
+        <p:txBody>
+          <a:bodyPr wrap="square"/>
+          <a:lstStyle/>
+          <a:p>
+            <a:pPr algn="l">
+              <a:defRPr sz="900" b="0">
+                <a:solidFill>
+                  <a:srgbClr val="374151"/>
+                </a:solidFill>
+                <a:latin typeface="Calibri"/>
+              </a:defRPr>
+            </a:pPr>
+            <a:r>
+              <a:t>$44</a:t>
+            </a:r>
+          </a:p>
+        </p:txBody>
+      </p:sp>
+      <p:sp>
+        <p:nvSpPr>
+          <p:cNvPr id="32" name="TextBox 31"/>
+          <p:cNvSpPr txBox="1"/>
+          <p:nvPr/>
+        </p:nvSpPr>
+        <p:spPr>
+          <a:xfrm>
+            <a:off x="5943600" y="2569464"/>
+            <a:ext cx="1051560" cy="256032"/>
+          </a:xfrm>
+          <a:prstGeom prst="rect">
+            <a:avLst/>
+          </a:prstGeom>
+          <a:noFill/>
+        </p:spPr>
+        <p:txBody>
+          <a:bodyPr wrap="square"/>
+          <a:lstStyle/>
+          <a:p>
+            <a:pPr algn="l">
+              <a:defRPr sz="900" b="0">
+                <a:solidFill>
+                  <a:srgbClr val="374151"/>
+                </a:solidFill>
+                <a:latin typeface="Calibri"/>
+              </a:defRPr>
+            </a:pPr>
+            <a:r>
+              <a:t>76.3%</a:t>
+            </a:r>
+          </a:p>
+        </p:txBody>
+      </p:sp>
+      <p:sp>
+        <p:nvSpPr>
+          <p:cNvPr id="33" name="Rectangle 32"/>
+          <p:cNvSpPr/>
+          <p:nvPr/>
+        </p:nvSpPr>
+        <p:spPr>
+          <a:xfrm>
+            <a:off x="685800" y="2798064"/>
+            <a:ext cx="6309360" cy="4572"/>
+          </a:xfrm>
+          <a:prstGeom prst="rect">
+            <a:avLst/>
+          </a:prstGeom>
+          <a:solidFill>
+            <a:srgbClr val="F3F4F6"/>
+          </a:solidFill>
+          <a:ln>
+            <a:noFill/>
+          </a:ln>
+        </p:spPr>
+        <p:style>
+          <a:lnRef idx="1">
+            <a:schemeClr val="accent1"/>
+          </a:lnRef>
+          <a:fillRef idx="3">
+            <a:schemeClr val="accent1"/>
+          </a:fillRef>
+          <a:effectRef idx="2">
+            <a:schemeClr val="accent1"/>
+          </a:effectRef>
+          <a:fontRef idx="minor">
+            <a:schemeClr val="lt1"/>
+          </a:fontRef>
+        </p:style>
+        <p:txBody>
+          <a:bodyPr rtlCol="0" anchor="ctr"/>
+          <a:lstStyle/>
+          <a:p>
+            <a:pPr algn="ctr"/>
+          </a:p>
+        </p:txBody>
+      </p:sp>
+      <p:sp>
+        <p:nvSpPr>
+          <p:cNvPr id="34" name="TextBox 33"/>
+          <p:cNvSpPr txBox="1"/>
+          <p:nvPr/>
+        </p:nvSpPr>
+        <p:spPr>
+          <a:xfrm>
+            <a:off x="685800" y="2825496"/>
+            <a:ext cx="1051560" cy="256032"/>
+          </a:xfrm>
+          <a:prstGeom prst="rect">
+            <a:avLst/>
+          </a:prstGeom>
+          <a:noFill/>
+        </p:spPr>
+        <p:txBody>
+          <a:bodyPr wrap="square"/>
+          <a:lstStyle/>
+          <a:p>
+            <a:pPr algn="l">
+              <a:defRPr sz="900" b="0">
+                <a:solidFill>
+                  <a:srgbClr val="374151"/>
+                </a:solidFill>
+                <a:latin typeface="Calibri"/>
+              </a:defRPr>
+            </a:pPr>
+            <a:r>
+              <a:t>DLRM Deep Model</a:t>
+            </a:r>
+          </a:p>
+        </p:txBody>
+      </p:sp>
+      <p:sp>
+        <p:nvSpPr>
+          <p:cNvPr id="35" name="TextBox 34"/>
+          <p:cNvSpPr txBox="1"/>
+          <p:nvPr/>
+        </p:nvSpPr>
+        <p:spPr>
+          <a:xfrm>
+            <a:off x="1737360" y="2825496"/>
+            <a:ext cx="1051560" cy="256032"/>
+          </a:xfrm>
+          <a:prstGeom prst="rect">
+            <a:avLst/>
+          </a:prstGeom>
+          <a:noFill/>
+        </p:spPr>
+        <p:txBody>
+          <a:bodyPr wrap="square"/>
+          <a:lstStyle/>
+          <a:p>
+            <a:pPr algn="l">
+              <a:defRPr sz="900" b="0">
+                <a:solidFill>
+                  <a:srgbClr val="374151"/>
+                </a:solidFill>
+                <a:latin typeface="Calibri"/>
+              </a:defRPr>
+            </a:pPr>
+            <a:r>
+              <a:t>$52.1K</a:t>
+            </a:r>
+          </a:p>
+        </p:txBody>
+      </p:sp>
+      <p:sp>
+        <p:nvSpPr>
+          <p:cNvPr id="36" name="TextBox 35"/>
+          <p:cNvSpPr txBox="1"/>
+          <p:nvPr/>
+        </p:nvSpPr>
+        <p:spPr>
+          <a:xfrm>
+            <a:off x="2788920" y="2825496"/>
+            <a:ext cx="1051560" cy="256032"/>
+          </a:xfrm>
+          <a:prstGeom prst="rect">
+            <a:avLst/>
+          </a:prstGeom>
+          <a:noFill/>
+        </p:spPr>
+        <p:txBody>
+          <a:bodyPr wrap="square"/>
+          <a:lstStyle/>
+          <a:p>
+            <a:pPr algn="l">
+              <a:defRPr sz="900" b="0">
+                <a:solidFill>
+                  <a:srgbClr val="374151"/>
+                </a:solidFill>
+                <a:latin typeface="Calibri"/>
+              </a:defRPr>
+            </a:pPr>
+            <a:r>
+              <a:t>78%</a:t>
+            </a:r>
+          </a:p>
+        </p:txBody>
+      </p:sp>
+      <p:sp>
+        <p:nvSpPr>
+          <p:cNvPr id="37" name="TextBox 36"/>
+          <p:cNvSpPr txBox="1"/>
+          <p:nvPr/>
+        </p:nvSpPr>
+        <p:spPr>
+          <a:xfrm>
+            <a:off x="3840480" y="2825496"/>
+            <a:ext cx="1051560" cy="256032"/>
+          </a:xfrm>
+          <a:prstGeom prst="rect">
+            <a:avLst/>
+          </a:prstGeom>
+          <a:noFill/>
+        </p:spPr>
+        <p:txBody>
+          <a:bodyPr wrap="square"/>
+          <a:lstStyle/>
+          <a:p>
+            <a:pPr algn="l">
+              <a:defRPr sz="900" b="0">
+                <a:solidFill>
+                  <a:srgbClr val="374151"/>
+                </a:solidFill>
+                <a:latin typeface="Calibri"/>
+              </a:defRPr>
+            </a:pPr>
+            <a:r>
+              <a:t>7</a:t>
+            </a:r>
+          </a:p>
+        </p:txBody>
+      </p:sp>
+      <p:sp>
+        <p:nvSpPr>
+          <p:cNvPr id="38" name="TextBox 37"/>
+          <p:cNvSpPr txBox="1"/>
+          <p:nvPr/>
+        </p:nvSpPr>
+        <p:spPr>
+          <a:xfrm>
+            <a:off x="4892040" y="2825496"/>
+            <a:ext cx="1051560" cy="256032"/>
+          </a:xfrm>
+          <a:prstGeom prst="rect">
+            <a:avLst/>
+          </a:prstGeom>
+          <a:noFill/>
+        </p:spPr>
+        <p:txBody>
+          <a:bodyPr wrap="square"/>
+          <a:lstStyle/>
+          <a:p>
+            <a:pPr algn="l">
+              <a:defRPr sz="900" b="0">
+                <a:solidFill>
+                  <a:srgbClr val="374151"/>
+                </a:solidFill>
+                <a:latin typeface="Calibri"/>
+              </a:defRPr>
+            </a:pPr>
+            <a:r>
+              <a:t>$36</a:t>
+            </a:r>
+          </a:p>
+        </p:txBody>
+      </p:sp>
+      <p:sp>
+        <p:nvSpPr>
+          <p:cNvPr id="39" name="TextBox 38"/>
+          <p:cNvSpPr txBox="1"/>
+          <p:nvPr/>
+        </p:nvSpPr>
+        <p:spPr>
+          <a:xfrm>
+            <a:off x="5943600" y="2825496"/>
+            <a:ext cx="1051560" cy="256032"/>
+          </a:xfrm>
+          <a:prstGeom prst="rect">
+            <a:avLst/>
+          </a:prstGeom>
+          <a:noFill/>
+        </p:spPr>
+        <p:txBody>
+          <a:bodyPr wrap="square"/>
+          <a:lstStyle/>
+          <a:p>
+            <a:pPr algn="l">
+              <a:defRPr sz="900" b="0">
+                <a:solidFill>
+                  <a:srgbClr val="374151"/>
+                </a:solidFill>
+                <a:latin typeface="Calibri"/>
+              </a:defRPr>
+            </a:pPr>
+            <a:r>
+              <a:t>73.8%</a:t>
+            </a:r>
+          </a:p>
+        </p:txBody>
+      </p:sp>
+      <p:sp>
+        <p:nvSpPr>
+          <p:cNvPr id="40" name="Rectangle 39"/>
+          <p:cNvSpPr/>
+          <p:nvPr/>
+        </p:nvSpPr>
+        <p:spPr>
+          <a:xfrm>
+            <a:off x="685800" y="3054096"/>
+            <a:ext cx="6309360" cy="4572"/>
+          </a:xfrm>
+          <a:prstGeom prst="rect">
+            <a:avLst/>
+          </a:prstGeom>
+          <a:solidFill>
+            <a:srgbClr val="F3F4F6"/>
+          </a:solidFill>
+          <a:ln>
+            <a:noFill/>
+          </a:ln>
+        </p:spPr>
+        <p:style>
+          <a:lnRef idx="1">
+            <a:schemeClr val="accent1"/>
+          </a:lnRef>
+          <a:fillRef idx="3">
+            <a:schemeClr val="accent1"/>
+          </a:fillRef>
+          <a:effectRef idx="2">
+            <a:schemeClr val="accent1"/>
+          </a:effectRef>
+          <a:fontRef idx="minor">
+            <a:schemeClr val="lt1"/>
+          </a:fontRef>
+        </p:style>
+        <p:txBody>
+          <a:bodyPr rtlCol="0" anchor="ctr"/>
+          <a:lstStyle/>
+          <a:p>
+            <a:pPr algn="ctr"/>
+          </a:p>
+        </p:txBody>
+      </p:sp>
+      <p:sp>
+        <p:nvSpPr>
+          <p:cNvPr id="41" name="TextBox 40"/>
+          <p:cNvSpPr txBox="1"/>
+          <p:nvPr/>
+        </p:nvSpPr>
+        <p:spPr>
+          <a:xfrm>
+            <a:off x="685800" y="3081528"/>
+            <a:ext cx="1051560" cy="256032"/>
+          </a:xfrm>
+          <a:prstGeom prst="rect">
+            <a:avLst/>
+          </a:prstGeom>
+          <a:noFill/>
+        </p:spPr>
+        <p:txBody>
+          <a:bodyPr wrap="square"/>
+          <a:lstStyle/>
+          <a:p>
+            <a:pPr algn="l">
+              <a:defRPr sz="900" b="0">
+                <a:solidFill>
+                  <a:srgbClr val="374151"/>
+                </a:solidFill>
+                <a:latin typeface="Calibri"/>
+              </a:defRPr>
+            </a:pPr>
+            <a:r>
+              <a:t>Contextual Bandit</a:t>
+            </a:r>
+          </a:p>
+        </p:txBody>
+      </p:sp>
+      <p:sp>
+        <p:nvSpPr>
+          <p:cNvPr id="42" name="TextBox 41"/>
+          <p:cNvSpPr txBox="1"/>
+          <p:nvPr/>
+        </p:nvSpPr>
+        <p:spPr>
+          <a:xfrm>
+            <a:off x="1737360" y="3081528"/>
+            <a:ext cx="1051560" cy="256032"/>
+          </a:xfrm>
+          <a:prstGeom prst="rect">
+            <a:avLst/>
+          </a:prstGeom>
+          <a:noFill/>
+        </p:spPr>
+        <p:txBody>
+          <a:bodyPr wrap="square"/>
+          <a:lstStyle/>
+          <a:p>
+            <a:pPr algn="l">
+              <a:defRPr sz="900" b="0">
+                <a:solidFill>
+                  <a:srgbClr val="374151"/>
+                </a:solidFill>
+                <a:latin typeface="Calibri"/>
+              </a:defRPr>
+            </a:pPr>
+            <a:r>
+              <a:t>$38.4K</a:t>
+            </a:r>
+          </a:p>
+        </p:txBody>
+      </p:sp>
+      <p:sp>
+        <p:nvSpPr>
+          <p:cNvPr id="43" name="TextBox 42"/>
+          <p:cNvSpPr txBox="1"/>
+          <p:nvPr/>
+        </p:nvSpPr>
+        <p:spPr>
+          <a:xfrm>
+            <a:off x="2788920" y="3081528"/>
+            <a:ext cx="1051560" cy="256032"/>
+          </a:xfrm>
+          <a:prstGeom prst="rect">
+            <a:avLst/>
+          </a:prstGeom>
+          <a:noFill/>
+        </p:spPr>
+        <p:txBody>
+          <a:bodyPr wrap="square"/>
+          <a:lstStyle/>
+          <a:p>
+            <a:pPr algn="l">
+              <a:defRPr sz="900" b="0">
+                <a:solidFill>
+                  <a:srgbClr val="374151"/>
+                </a:solidFill>
+                <a:latin typeface="Calibri"/>
+              </a:defRPr>
+            </a:pPr>
+            <a:r>
+              <a:t>81%</a:t>
+            </a:r>
+          </a:p>
+        </p:txBody>
+      </p:sp>
+      <p:sp>
+        <p:nvSpPr>
+          <p:cNvPr id="44" name="TextBox 43"/>
+          <p:cNvSpPr txBox="1"/>
+          <p:nvPr/>
+        </p:nvSpPr>
+        <p:spPr>
+          <a:xfrm>
+            <a:off x="3840480" y="3081528"/>
+            <a:ext cx="1051560" cy="256032"/>
+          </a:xfrm>
+          <a:prstGeom prst="rect">
+            <a:avLst/>
+          </a:prstGeom>
+          <a:noFill/>
+        </p:spPr>
+        <p:txBody>
+          <a:bodyPr wrap="square"/>
+          <a:lstStyle/>
+          <a:p>
+            <a:pPr algn="l">
+              <a:defRPr sz="900" b="0">
+                <a:solidFill>
+                  <a:srgbClr val="374151"/>
+                </a:solidFill>
+                <a:latin typeface="Calibri"/>
+              </a:defRPr>
+            </a:pPr>
+            <a:r>
+              <a:t>6</a:t>
+            </a:r>
+          </a:p>
+        </p:txBody>
+      </p:sp>
+      <p:sp>
+        <p:nvSpPr>
+          <p:cNvPr id="45" name="TextBox 44"/>
+          <p:cNvSpPr txBox="1"/>
+          <p:nvPr/>
+        </p:nvSpPr>
+        <p:spPr>
+          <a:xfrm>
+            <a:off x="4892040" y="3081528"/>
+            <a:ext cx="1051560" cy="256032"/>
+          </a:xfrm>
+          <a:prstGeom prst="rect">
+            <a:avLst/>
+          </a:prstGeom>
+          <a:noFill/>
+        </p:spPr>
+        <p:txBody>
+          <a:bodyPr wrap="square"/>
+          <a:lstStyle/>
+          <a:p>
+            <a:pPr algn="l">
+              <a:defRPr sz="900" b="0">
+                <a:solidFill>
+                  <a:srgbClr val="374151"/>
+                </a:solidFill>
+                <a:latin typeface="Calibri"/>
+              </a:defRPr>
+            </a:pPr>
+            <a:r>
+              <a:t>$51</a:t>
+            </a:r>
+          </a:p>
+        </p:txBody>
+      </p:sp>
+      <p:sp>
+        <p:nvSpPr>
+          <p:cNvPr id="46" name="TextBox 45"/>
+          <p:cNvSpPr txBox="1"/>
+          <p:nvPr/>
+        </p:nvSpPr>
+        <p:spPr>
+          <a:xfrm>
+            <a:off x="5943600" y="3081528"/>
+            <a:ext cx="1051560" cy="256032"/>
+          </a:xfrm>
+          <a:prstGeom prst="rect">
+            <a:avLst/>
+          </a:prstGeom>
+          <a:noFill/>
+        </p:spPr>
+        <p:txBody>
+          <a:bodyPr wrap="square"/>
+          <a:lstStyle/>
+          <a:p>
+            <a:pPr algn="l">
+              <a:defRPr sz="900" b="0">
+                <a:solidFill>
+                  <a:srgbClr val="374151"/>
+                </a:solidFill>
+                <a:latin typeface="Calibri"/>
+              </a:defRPr>
+            </a:pPr>
+            <a:r>
+              <a:t>68.5%</a:t>
+            </a:r>
+          </a:p>
+        </p:txBody>
+      </p:sp>
+      <p:sp>
+        <p:nvSpPr>
+          <p:cNvPr id="47" name="Rectangle 46"/>
+          <p:cNvSpPr/>
+          <p:nvPr/>
+        </p:nvSpPr>
+        <p:spPr>
+          <a:xfrm>
+            <a:off x="685800" y="3310128"/>
+            <a:ext cx="6309360" cy="4572"/>
+          </a:xfrm>
+          <a:prstGeom prst="rect">
+            <a:avLst/>
+          </a:prstGeom>
+          <a:solidFill>
+            <a:srgbClr val="F3F4F6"/>
+          </a:solidFill>
+          <a:ln>
+            <a:noFill/>
+          </a:ln>
+        </p:spPr>
+        <p:style>
+          <a:lnRef idx="1">
+            <a:schemeClr val="accent1"/>
+          </a:lnRef>
+          <a:fillRef idx="3">
+            <a:schemeClr val="accent1"/>
+          </a:fillRef>
+          <a:effectRef idx="2">
+            <a:schemeClr val="accent1"/>
+          </a:effectRef>
+          <a:fontRef idx="minor">
+            <a:schemeClr val="lt1"/>
+          </a:fontRef>
+        </p:style>
+        <p:txBody>
+          <a:bodyPr rtlCol="0" anchor="ctr"/>
+          <a:lstStyle/>
+          <a:p>
+            <a:pPr algn="ctr"/>
+          </a:p>
+        </p:txBody>
+      </p:sp>
+      <p:sp>
+        <p:nvSpPr>
+          <p:cNvPr id="48" name="TextBox 47"/>
+          <p:cNvSpPr txBox="1"/>
+          <p:nvPr/>
+        </p:nvSpPr>
+        <p:spPr>
+          <a:xfrm>
+            <a:off x="685800" y="3337560"/>
+            <a:ext cx="1051560" cy="256032"/>
+          </a:xfrm>
+          <a:prstGeom prst="rect">
+            <a:avLst/>
+          </a:prstGeom>
+          <a:noFill/>
+        </p:spPr>
+        <p:txBody>
+          <a:bodyPr wrap="square"/>
+          <a:lstStyle/>
+          <a:p>
+            <a:pPr algn="l">
+              <a:defRPr sz="900" b="0">
+                <a:solidFill>
+                  <a:srgbClr val="374151"/>
+                </a:solidFill>
+                <a:latin typeface="Calibri"/>
+              </a:defRPr>
+            </a:pPr>
+            <a:r>
+              <a:t>Two-Tower (ANN)</a:t>
+            </a:r>
+          </a:p>
+        </p:txBody>
+      </p:sp>
+      <p:sp>
+        <p:nvSpPr>
+          <p:cNvPr id="49" name="TextBox 48"/>
+          <p:cNvSpPr txBox="1"/>
+          <p:nvPr/>
+        </p:nvSpPr>
+        <p:spPr>
+          <a:xfrm>
+            <a:off x="1737360" y="3337560"/>
+            <a:ext cx="1051560" cy="256032"/>
+          </a:xfrm>
+          <a:prstGeom prst="rect">
+            <a:avLst/>
+          </a:prstGeom>
+          <a:noFill/>
+        </p:spPr>
+        <p:txBody>
+          <a:bodyPr wrap="square"/>
+          <a:lstStyle/>
+          <a:p>
+            <a:pPr algn="l">
+              <a:defRPr sz="900" b="0">
+                <a:solidFill>
+                  <a:srgbClr val="374151"/>
+                </a:solidFill>
+                <a:latin typeface="Calibri"/>
+              </a:defRPr>
+            </a:pPr>
+            <a:r>
+              <a:t>$35.9K</a:t>
+            </a:r>
+          </a:p>
+        </p:txBody>
+      </p:sp>
+      <p:sp>
+        <p:nvSpPr>
+          <p:cNvPr id="50" name="TextBox 49"/>
+          <p:cNvSpPr txBox="1"/>
+          <p:nvPr/>
+        </p:nvSpPr>
+        <p:spPr>
+          <a:xfrm>
+            <a:off x="2788920" y="3337560"/>
+            <a:ext cx="1051560" cy="256032"/>
+          </a:xfrm>
+          <a:prstGeom prst="rect">
+            <a:avLst/>
+          </a:prstGeom>
+          <a:noFill/>
+        </p:spPr>
+        <p:txBody>
+          <a:bodyPr wrap="square"/>
+          <a:lstStyle/>
+          <a:p>
+            <a:pPr algn="l">
+              <a:defRPr sz="900" b="0">
+                <a:solidFill>
+                  <a:srgbClr val="374151"/>
+                </a:solidFill>
+                <a:latin typeface="Calibri"/>
+              </a:defRPr>
+            </a:pPr>
+            <a:r>
+              <a:t>79%</a:t>
+            </a:r>
+          </a:p>
+        </p:txBody>
+      </p:sp>
+      <p:sp>
+        <p:nvSpPr>
+          <p:cNvPr id="51" name="TextBox 50"/>
+          <p:cNvSpPr txBox="1"/>
+          <p:nvPr/>
+        </p:nvSpPr>
+        <p:spPr>
+          <a:xfrm>
+            <a:off x="3840480" y="3337560"/>
+            <a:ext cx="1051560" cy="256032"/>
+          </a:xfrm>
+          <a:prstGeom prst="rect">
+            <a:avLst/>
+          </a:prstGeom>
+          <a:noFill/>
+        </p:spPr>
+        <p:txBody>
+          <a:bodyPr wrap="square"/>
+          <a:lstStyle/>
+          <a:p>
+            <a:pPr algn="l">
+              <a:defRPr sz="900" b="0">
+                <a:solidFill>
+                  <a:srgbClr val="374151"/>
+                </a:solidFill>
+                <a:latin typeface="Calibri"/>
+              </a:defRPr>
+            </a:pPr>
+            <a:r>
+              <a:t>8</a:t>
+            </a:r>
+          </a:p>
+        </p:txBody>
+      </p:sp>
+      <p:sp>
+        <p:nvSpPr>
+          <p:cNvPr id="52" name="TextBox 51"/>
+          <p:cNvSpPr txBox="1"/>
+          <p:nvPr/>
+        </p:nvSpPr>
+        <p:spPr>
+          <a:xfrm>
+            <a:off x="4892040" y="3337560"/>
+            <a:ext cx="1051560" cy="256032"/>
+          </a:xfrm>
+          <a:prstGeom prst="rect">
+            <a:avLst/>
+          </a:prstGeom>
+          <a:noFill/>
+        </p:spPr>
+        <p:txBody>
+          <a:bodyPr wrap="square"/>
+          <a:lstStyle/>
+          <a:p>
+            <a:pPr algn="l">
+              <a:defRPr sz="900" b="0">
+                <a:solidFill>
+                  <a:srgbClr val="374151"/>
+                </a:solidFill>
+                <a:latin typeface="Calibri"/>
+              </a:defRPr>
+            </a:pPr>
+            <a:r>
+              <a:t>$55</a:t>
+            </a:r>
+          </a:p>
+        </p:txBody>
+      </p:sp>
+      <p:sp>
+        <p:nvSpPr>
+          <p:cNvPr id="53" name="TextBox 52"/>
+          <p:cNvSpPr txBox="1"/>
+          <p:nvPr/>
+        </p:nvSpPr>
+        <p:spPr>
+          <a:xfrm>
+            <a:off x="5943600" y="3337560"/>
+            <a:ext cx="1051560" cy="256032"/>
+          </a:xfrm>
+          <a:prstGeom prst="rect">
+            <a:avLst/>
+          </a:prstGeom>
+          <a:noFill/>
+        </p:spPr>
+        <p:txBody>
+          <a:bodyPr wrap="square"/>
+          <a:lstStyle/>
+          <a:p>
+            <a:pPr algn="l">
+              <a:defRPr sz="900" b="0">
+                <a:solidFill>
+                  <a:srgbClr val="374151"/>
+                </a:solidFill>
+                <a:latin typeface="Calibri"/>
+              </a:defRPr>
+            </a:pPr>
+            <a:r>
+              <a:t>62.1%</a:t>
+            </a:r>
+          </a:p>
+        </p:txBody>
+      </p:sp>
+      <p:sp>
+        <p:nvSpPr>
+          <p:cNvPr id="54" name="Rectangle 53"/>
+          <p:cNvSpPr/>
+          <p:nvPr/>
+        </p:nvSpPr>
+        <p:spPr>
+          <a:xfrm>
+            <a:off x="685800" y="3566160"/>
+            <a:ext cx="6309360" cy="4572"/>
+          </a:xfrm>
+          <a:prstGeom prst="rect">
+            <a:avLst/>
+          </a:prstGeom>
+          <a:solidFill>
+            <a:srgbClr val="F3F4F6"/>
+          </a:solidFill>
+          <a:ln>
+            <a:noFill/>
+          </a:ln>
+        </p:spPr>
+        <p:style>
+          <a:lnRef idx="1">
+            <a:schemeClr val="accent1"/>
+          </a:lnRef>
+          <a:fillRef idx="3">
+            <a:schemeClr val="accent1"/>
+          </a:fillRef>
+          <a:effectRef idx="2">
+            <a:schemeClr val="accent1"/>
+          </a:effectRef>
+          <a:fontRef idx="minor">
+            <a:schemeClr val="lt1"/>
+          </a:fontRef>
+        </p:style>
+        <p:txBody>
+          <a:bodyPr rtlCol="0" anchor="ctr"/>
+          <a:lstStyle/>
+          <a:p>
+            <a:pPr algn="ctr"/>
+          </a:p>
+        </p:txBody>
+      </p:sp>
+      <p:sp>
+        <p:nvSpPr>
+          <p:cNvPr id="55" name="Rectangle 54"/>
+          <p:cNvSpPr/>
+          <p:nvPr/>
+        </p:nvSpPr>
+        <p:spPr>
+          <a:xfrm>
+            <a:off x="7498079" y="1371600"/>
+            <a:ext cx="4114800" cy="2926080"/>
+          </a:xfrm>
+          <a:prstGeom prst="rect">
+            <a:avLst/>
+          </a:prstGeom>
+          <a:solidFill>
+            <a:srgbClr val="FFFFFF"/>
+          </a:solidFill>
+          <a:ln>
+            <a:noFill/>
+          </a:ln>
+        </p:spPr>
+        <p:style>
+          <a:lnRef idx="1">
+            <a:schemeClr val="accent1"/>
+          </a:lnRef>
+          <a:fillRef idx="3">
+            <a:schemeClr val="accent1"/>
+          </a:fillRef>
+          <a:effectRef idx="2">
+            <a:schemeClr val="accent1"/>
+          </a:effectRef>
+          <a:fontRef idx="minor">
+            <a:schemeClr val="lt1"/>
+          </a:fontRef>
+        </p:style>
+        <p:txBody>
+          <a:bodyPr rtlCol="0" anchor="ctr"/>
+          <a:lstStyle/>
+          <a:p>
+            <a:pPr algn="ctr"/>
+          </a:p>
+        </p:txBody>
+      </p:sp>
+      <p:sp>
+        <p:nvSpPr>
+          <p:cNvPr id="56" name="TextBox 55"/>
+          <p:cNvSpPr txBox="1"/>
+          <p:nvPr/>
+        </p:nvSpPr>
+        <p:spPr>
+          <a:xfrm>
+            <a:off x="7680960" y="1463040"/>
+            <a:ext cx="3657600" cy="274320"/>
+          </a:xfrm>
+          <a:prstGeom prst="rect">
+            <a:avLst/>
+          </a:prstGeom>
+          <a:noFill/>
+        </p:spPr>
+        <p:txBody>
+          <a:bodyPr wrap="square"/>
+          <a:lstStyle/>
+          <a:p>
+            <a:pPr algn="l">
+              <a:defRPr sz="1200" b="1">
+                <a:solidFill>
+                  <a:srgbClr val="111827"/>
+                </a:solidFill>
+                <a:latin typeface="Calibri"/>
+              </a:defRPr>
+            </a:pPr>
+            <a:r>
+              <a:t>Finance Sub-Verticals</a:t>
+            </a:r>
+          </a:p>
+        </p:txBody>
+      </p:sp>
+      <p:sp>
+        <p:nvSpPr>
+          <p:cNvPr id="57" name="Rectangle 56"/>
+          <p:cNvSpPr/>
+          <p:nvPr/>
+        </p:nvSpPr>
+        <p:spPr>
+          <a:xfrm>
+            <a:off x="7680960" y="1920240"/>
+            <a:ext cx="54864" cy="320040"/>
+          </a:xfrm>
+          <a:prstGeom prst="rect">
+            <a:avLst/>
+          </a:prstGeom>
+          <a:solidFill>
+            <a:srgbClr val="1D4ED8"/>
+          </a:solidFill>
+          <a:ln>
+            <a:noFill/>
+          </a:ln>
+        </p:spPr>
+        <p:style>
+          <a:lnRef idx="1">
+            <a:schemeClr val="accent1"/>
+          </a:lnRef>
+          <a:fillRef idx="3">
+            <a:schemeClr val="accent1"/>
+          </a:fillRef>
+          <a:effectRef idx="2">
+            <a:schemeClr val="accent1"/>
+          </a:effectRef>
+          <a:fontRef idx="minor">
+            <a:schemeClr val="lt1"/>
+          </a:fontRef>
+        </p:style>
+        <p:txBody>
+          <a:bodyPr rtlCol="0" anchor="ctr"/>
+          <a:lstStyle/>
+          <a:p>
+            <a:pPr algn="ctr"/>
+          </a:p>
+        </p:txBody>
+      </p:sp>
+      <p:sp>
+        <p:nvSpPr>
+          <p:cNvPr id="58" name="TextBox 57"/>
+          <p:cNvSpPr txBox="1"/>
+          <p:nvPr/>
+        </p:nvSpPr>
+        <p:spPr>
+          <a:xfrm>
+            <a:off x="7863840" y="1920240"/>
+            <a:ext cx="1828800" cy="182880"/>
+          </a:xfrm>
+          <a:prstGeom prst="rect">
+            <a:avLst/>
+          </a:prstGeom>
+          <a:noFill/>
+        </p:spPr>
+        <p:txBody>
+          <a:bodyPr wrap="square"/>
+          <a:lstStyle/>
+          <a:p>
+            <a:pPr algn="l">
+              <a:defRPr sz="1000" b="1">
+                <a:solidFill>
+                  <a:srgbClr val="1D4ED8"/>
+                </a:solidFill>
+                <a:latin typeface="Calibri"/>
+              </a:defRPr>
+            </a:pPr>
+            <a:r>
+              <a:t>Credit Cards</a:t>
+            </a:r>
+          </a:p>
+        </p:txBody>
+      </p:sp>
+      <p:sp>
+        <p:nvSpPr>
+          <p:cNvPr id="59" name="TextBox 58"/>
+          <p:cNvSpPr txBox="1"/>
+          <p:nvPr/>
+        </p:nvSpPr>
+        <p:spPr>
+          <a:xfrm>
+            <a:off x="7863840" y="2103120"/>
+            <a:ext cx="3474720" cy="182880"/>
+          </a:xfrm>
+          <a:prstGeom prst="rect">
+            <a:avLst/>
+          </a:prstGeom>
+          <a:noFill/>
+        </p:spPr>
+        <p:txBody>
+          <a:bodyPr wrap="square"/>
+          <a:lstStyle/>
+          <a:p>
+            <a:pPr algn="l">
+              <a:defRPr sz="800" b="0">
+                <a:solidFill>
+                  <a:srgbClr val="6B7280"/>
+                </a:solidFill>
+                <a:latin typeface="Calibri"/>
+              </a:defRPr>
+            </a:pPr>
+            <a:r>
+              <a:t>Trust: 85% · Reg Risk: 40% · Window: 21d</a:t>
+            </a:r>
+          </a:p>
+        </p:txBody>
+      </p:sp>
+      <p:sp>
+        <p:nvSpPr>
+          <p:cNvPr id="60" name="Rectangle 59"/>
+          <p:cNvSpPr/>
+          <p:nvPr/>
+        </p:nvSpPr>
+        <p:spPr>
+          <a:xfrm>
+            <a:off x="7680960" y="2377440"/>
+            <a:ext cx="54864" cy="320040"/>
+          </a:xfrm>
+          <a:prstGeom prst="rect">
+            <a:avLst/>
+          </a:prstGeom>
+          <a:solidFill>
+            <a:srgbClr val="0891B2"/>
+          </a:solidFill>
+          <a:ln>
+            <a:noFill/>
+          </a:ln>
+        </p:spPr>
+        <p:style>
+          <a:lnRef idx="1">
+            <a:schemeClr val="accent1"/>
+          </a:lnRef>
+          <a:fillRef idx="3">
+            <a:schemeClr val="accent1"/>
+          </a:fillRef>
+          <a:effectRef idx="2">
+            <a:schemeClr val="accent1"/>
+          </a:effectRef>
+          <a:fontRef idx="minor">
+            <a:schemeClr val="lt1"/>
+          </a:fontRef>
+        </p:style>
+        <p:txBody>
+          <a:bodyPr rtlCol="0" anchor="ctr"/>
+          <a:lstStyle/>
+          <a:p>
+            <a:pPr algn="ctr"/>
+          </a:p>
+        </p:txBody>
+      </p:sp>
+      <p:sp>
+        <p:nvSpPr>
+          <p:cNvPr id="61" name="TextBox 60"/>
+          <p:cNvSpPr txBox="1"/>
+          <p:nvPr/>
+        </p:nvSpPr>
+        <p:spPr>
+          <a:xfrm>
+            <a:off x="7863840" y="2377440"/>
+            <a:ext cx="1828800" cy="182880"/>
+          </a:xfrm>
+          <a:prstGeom prst="rect">
+            <a:avLst/>
+          </a:prstGeom>
+          <a:noFill/>
+        </p:spPr>
+        <p:txBody>
+          <a:bodyPr wrap="square"/>
+          <a:lstStyle/>
+          <a:p>
+            <a:pPr algn="l">
+              <a:defRPr sz="1000" b="1">
+                <a:solidFill>
+                  <a:srgbClr val="0891B2"/>
+                </a:solidFill>
+                <a:latin typeface="Calibri"/>
+              </a:defRPr>
+            </a:pPr>
+            <a:r>
+              <a:t>Personal Loans</a:t>
+            </a:r>
+          </a:p>
+        </p:txBody>
+      </p:sp>
+      <p:sp>
+        <p:nvSpPr>
+          <p:cNvPr id="62" name="TextBox 61"/>
+          <p:cNvSpPr txBox="1"/>
+          <p:nvPr/>
+        </p:nvSpPr>
+        <p:spPr>
+          <a:xfrm>
+            <a:off x="7863840" y="2560320"/>
+            <a:ext cx="3474720" cy="182880"/>
+          </a:xfrm>
+          <a:prstGeom prst="rect">
+            <a:avLst/>
+          </a:prstGeom>
+          <a:noFill/>
+        </p:spPr>
+        <p:txBody>
+          <a:bodyPr wrap="square"/>
+          <a:lstStyle/>
+          <a:p>
+            <a:pPr algn="l">
+              <a:defRPr sz="800" b="0">
+                <a:solidFill>
+                  <a:srgbClr val="6B7280"/>
+                </a:solidFill>
+                <a:latin typeface="Calibri"/>
+              </a:defRPr>
+            </a:pPr>
+            <a:r>
+              <a:t>Trust: 90% · Reg Risk: 55% · Window: 30d</a:t>
+            </a:r>
+          </a:p>
+        </p:txBody>
+      </p:sp>
+      <p:sp>
+        <p:nvSpPr>
+          <p:cNvPr id="63" name="Rectangle 62"/>
+          <p:cNvSpPr/>
+          <p:nvPr/>
+        </p:nvSpPr>
+        <p:spPr>
+          <a:xfrm>
+            <a:off x="7680960" y="2834640"/>
+            <a:ext cx="54864" cy="320040"/>
+          </a:xfrm>
+          <a:prstGeom prst="rect">
+            <a:avLst/>
+          </a:prstGeom>
+          <a:solidFill>
+            <a:srgbClr val="16A34A"/>
+          </a:solidFill>
+          <a:ln>
+            <a:noFill/>
+          </a:ln>
+        </p:spPr>
+        <p:style>
+          <a:lnRef idx="1">
+            <a:schemeClr val="accent1"/>
+          </a:lnRef>
+          <a:fillRef idx="3">
+            <a:schemeClr val="accent1"/>
+          </a:fillRef>
+          <a:effectRef idx="2">
+            <a:schemeClr val="accent1"/>
+          </a:effectRef>
+          <a:fontRef idx="minor">
+            <a:schemeClr val="lt1"/>
+          </a:fontRef>
+        </p:style>
+        <p:txBody>
+          <a:bodyPr rtlCol="0" anchor="ctr"/>
+          <a:lstStyle/>
+          <a:p>
+            <a:pPr algn="ctr"/>
+          </a:p>
+        </p:txBody>
+      </p:sp>
+      <p:sp>
+        <p:nvSpPr>
+          <p:cNvPr id="64" name="TextBox 63"/>
+          <p:cNvSpPr txBox="1"/>
+          <p:nvPr/>
+        </p:nvSpPr>
+        <p:spPr>
+          <a:xfrm>
+            <a:off x="7863840" y="2834640"/>
+            <a:ext cx="1828800" cy="182880"/>
+          </a:xfrm>
+          <a:prstGeom prst="rect">
+            <a:avLst/>
+          </a:prstGeom>
+          <a:noFill/>
+        </p:spPr>
+        <p:txBody>
+          <a:bodyPr wrap="square"/>
+          <a:lstStyle/>
+          <a:p>
+            <a:pPr algn="l">
+              <a:defRPr sz="1000" b="1">
+                <a:solidFill>
+                  <a:srgbClr val="16A34A"/>
+                </a:solidFill>
+                <a:latin typeface="Calibri"/>
+              </a:defRPr>
+            </a:pPr>
+            <a:r>
+              <a:t>Insurance</a:t>
+            </a:r>
+          </a:p>
+        </p:txBody>
+      </p:sp>
+      <p:sp>
+        <p:nvSpPr>
+          <p:cNvPr id="65" name="TextBox 64"/>
+          <p:cNvSpPr txBox="1"/>
+          <p:nvPr/>
+        </p:nvSpPr>
+        <p:spPr>
+          <a:xfrm>
+            <a:off x="7863840" y="3017520"/>
+            <a:ext cx="3474720" cy="182880"/>
+          </a:xfrm>
+          <a:prstGeom prst="rect">
+            <a:avLst/>
+          </a:prstGeom>
+          <a:noFill/>
+        </p:spPr>
+        <p:txBody>
+          <a:bodyPr wrap="square"/>
+          <a:lstStyle/>
+          <a:p>
+            <a:pPr algn="l">
+              <a:defRPr sz="800" b="0">
+                <a:solidFill>
+                  <a:srgbClr val="6B7280"/>
+                </a:solidFill>
+                <a:latin typeface="Calibri"/>
+              </a:defRPr>
+            </a:pPr>
+            <a:r>
+              <a:t>Trust: 80% · Reg Risk: 45% · Window: 14d</a:t>
+            </a:r>
+          </a:p>
+        </p:txBody>
+      </p:sp>
+      <p:sp>
+        <p:nvSpPr>
+          <p:cNvPr id="66" name="Rectangle 65"/>
+          <p:cNvSpPr/>
+          <p:nvPr/>
+        </p:nvSpPr>
+        <p:spPr>
+          <a:xfrm>
+            <a:off x="7680960" y="3291840"/>
+            <a:ext cx="54864" cy="320040"/>
+          </a:xfrm>
+          <a:prstGeom prst="rect">
+            <a:avLst/>
+          </a:prstGeom>
+          <a:solidFill>
+            <a:srgbClr val="7C3AED"/>
+          </a:solidFill>
+          <a:ln>
+            <a:noFill/>
+          </a:ln>
+        </p:spPr>
+        <p:style>
+          <a:lnRef idx="1">
+            <a:schemeClr val="accent1"/>
+          </a:lnRef>
+          <a:fillRef idx="3">
+            <a:schemeClr val="accent1"/>
+          </a:fillRef>
+          <a:effectRef idx="2">
+            <a:schemeClr val="accent1"/>
+          </a:effectRef>
+          <a:fontRef idx="minor">
+            <a:schemeClr val="lt1"/>
+          </a:fontRef>
+        </p:style>
+        <p:txBody>
+          <a:bodyPr rtlCol="0" anchor="ctr"/>
+          <a:lstStyle/>
+          <a:p>
+            <a:pPr algn="ctr"/>
+          </a:p>
+        </p:txBody>
+      </p:sp>
+      <p:sp>
+        <p:nvSpPr>
+          <p:cNvPr id="67" name="TextBox 66"/>
+          <p:cNvSpPr txBox="1"/>
+          <p:nvPr/>
+        </p:nvSpPr>
+        <p:spPr>
+          <a:xfrm>
+            <a:off x="7863840" y="3291840"/>
+            <a:ext cx="1828800" cy="182880"/>
+          </a:xfrm>
+          <a:prstGeom prst="rect">
+            <a:avLst/>
+          </a:prstGeom>
+          <a:noFill/>
+        </p:spPr>
+        <p:txBody>
+          <a:bodyPr wrap="square"/>
+          <a:lstStyle/>
+          <a:p>
+            <a:pPr algn="l">
+              <a:defRPr sz="1000" b="1">
+                <a:solidFill>
+                  <a:srgbClr val="7C3AED"/>
+                </a:solidFill>
+                <a:latin typeface="Calibri"/>
+              </a:defRPr>
+            </a:pPr>
+            <a:r>
+              <a:t>Investment Platforms</a:t>
+            </a:r>
+          </a:p>
+        </p:txBody>
+      </p:sp>
+      <p:sp>
+        <p:nvSpPr>
+          <p:cNvPr id="68" name="TextBox 67"/>
+          <p:cNvSpPr txBox="1"/>
+          <p:nvPr/>
+        </p:nvSpPr>
+        <p:spPr>
+          <a:xfrm>
+            <a:off x="7863840" y="3474720"/>
+            <a:ext cx="3474720" cy="182880"/>
+          </a:xfrm>
+          <a:prstGeom prst="rect">
+            <a:avLst/>
+          </a:prstGeom>
+          <a:noFill/>
+        </p:spPr>
+        <p:txBody>
+          <a:bodyPr wrap="square"/>
+          <a:lstStyle/>
+          <a:p>
+            <a:pPr algn="l">
+              <a:defRPr sz="800" b="0">
+                <a:solidFill>
+                  <a:srgbClr val="6B7280"/>
+                </a:solidFill>
+                <a:latin typeface="Calibri"/>
+              </a:defRPr>
+            </a:pPr>
+            <a:r>
+              <a:t>Trust: 95% · Reg Risk: 65% · Window: 45d</a:t>
+            </a:r>
+          </a:p>
+        </p:txBody>
+      </p:sp>
+      <p:sp>
+        <p:nvSpPr>
+          <p:cNvPr id="69" name="Rectangle 68"/>
+          <p:cNvSpPr/>
+          <p:nvPr/>
+        </p:nvSpPr>
+        <p:spPr>
+          <a:xfrm>
+            <a:off x="7680960" y="3749039"/>
+            <a:ext cx="54864" cy="320040"/>
+          </a:xfrm>
+          <a:prstGeom prst="rect">
+            <a:avLst/>
+          </a:prstGeom>
+          <a:solidFill>
+            <a:srgbClr val="CA8A04"/>
+          </a:solidFill>
+          <a:ln>
+            <a:noFill/>
+          </a:ln>
+        </p:spPr>
+        <p:style>
+          <a:lnRef idx="1">
+            <a:schemeClr val="accent1"/>
+          </a:lnRef>
+          <a:fillRef idx="3">
+            <a:schemeClr val="accent1"/>
+          </a:fillRef>
+          <a:effectRef idx="2">
+            <a:schemeClr val="accent1"/>
+          </a:effectRef>
+          <a:fontRef idx="minor">
+            <a:schemeClr val="lt1"/>
+          </a:fontRef>
+        </p:style>
+        <p:txBody>
+          <a:bodyPr rtlCol="0" anchor="ctr"/>
+          <a:lstStyle/>
+          <a:p>
+            <a:pPr algn="ctr"/>
+          </a:p>
+        </p:txBody>
+      </p:sp>
+      <p:sp>
+        <p:nvSpPr>
+          <p:cNvPr id="70" name="TextBox 69"/>
+          <p:cNvSpPr txBox="1"/>
+          <p:nvPr/>
+        </p:nvSpPr>
+        <p:spPr>
+          <a:xfrm>
+            <a:off x="7863840" y="3749039"/>
+            <a:ext cx="1828800" cy="182880"/>
+          </a:xfrm>
+          <a:prstGeom prst="rect">
+            <a:avLst/>
+          </a:prstGeom>
+          <a:noFill/>
+        </p:spPr>
+        <p:txBody>
+          <a:bodyPr wrap="square"/>
+          <a:lstStyle/>
+          <a:p>
+            <a:pPr algn="l">
+              <a:defRPr sz="1000" b="1">
+                <a:solidFill>
+                  <a:srgbClr val="CA8A04"/>
+                </a:solidFill>
+                <a:latin typeface="Calibri"/>
+              </a:defRPr>
+            </a:pPr>
+            <a:r>
+              <a:t>Neobanks</a:t>
+            </a:r>
+          </a:p>
+        </p:txBody>
+      </p:sp>
+      <p:sp>
+        <p:nvSpPr>
+          <p:cNvPr id="71" name="TextBox 70"/>
+          <p:cNvSpPr txBox="1"/>
+          <p:nvPr/>
+        </p:nvSpPr>
+        <p:spPr>
+          <a:xfrm>
+            <a:off x="7863840" y="3931920"/>
+            <a:ext cx="3474720" cy="182880"/>
+          </a:xfrm>
+          <a:prstGeom prst="rect">
+            <a:avLst/>
+          </a:prstGeom>
+          <a:noFill/>
+        </p:spPr>
+        <p:txBody>
+          <a:bodyPr wrap="square"/>
+          <a:lstStyle/>
+          <a:p>
+            <a:pPr algn="l">
+              <a:defRPr sz="800" b="0">
+                <a:solidFill>
+                  <a:srgbClr val="6B7280"/>
+                </a:solidFill>
+                <a:latin typeface="Calibri"/>
+              </a:defRPr>
+            </a:pPr>
+            <a:r>
+              <a:t>Trust: 70% · Reg Risk: 30% · Window: 14d</a:t>
+            </a:r>
+          </a:p>
+        </p:txBody>
+      </p:sp>
+      <p:sp>
+        <p:nvSpPr>
+          <p:cNvPr id="72" name="Rectangle 71"/>
+          <p:cNvSpPr/>
+          <p:nvPr/>
+        </p:nvSpPr>
+        <p:spPr>
+          <a:xfrm>
+            <a:off x="548640" y="4572000"/>
+            <a:ext cx="3520440" cy="1005840"/>
+          </a:xfrm>
+          <a:prstGeom prst="rect">
+            <a:avLst/>
+          </a:prstGeom>
+          <a:solidFill>
+            <a:srgbClr val="FFFFFF"/>
+          </a:solidFill>
+          <a:ln>
+            <a:noFill/>
+          </a:ln>
+        </p:spPr>
+        <p:style>
+          <a:lnRef idx="1">
+            <a:schemeClr val="accent1"/>
+          </a:lnRef>
+          <a:fillRef idx="3">
+            <a:schemeClr val="accent1"/>
+          </a:fillRef>
+          <a:effectRef idx="2">
+            <a:schemeClr val="accent1"/>
+          </a:effectRef>
+          <a:fontRef idx="minor">
+            <a:schemeClr val="lt1"/>
+          </a:fontRef>
+        </p:style>
+        <p:txBody>
+          <a:bodyPr rtlCol="0" anchor="ctr"/>
+          <a:lstStyle/>
+          <a:p>
+            <a:pPr algn="ctr"/>
+          </a:p>
+        </p:txBody>
+      </p:sp>
+      <p:sp>
+        <p:nvSpPr>
+          <p:cNvPr id="73" name="Rectangle 72"/>
+          <p:cNvSpPr/>
+          <p:nvPr/>
+        </p:nvSpPr>
+        <p:spPr>
+          <a:xfrm>
+            <a:off x="548640" y="4572000"/>
+            <a:ext cx="3520440" cy="54864"/>
+          </a:xfrm>
+          <a:prstGeom prst="rect">
+            <a:avLst/>
+          </a:prstGeom>
+          <a:solidFill>
+            <a:srgbClr val="1D4ED8"/>
+          </a:solidFill>
+          <a:ln>
+            <a:noFill/>
+          </a:ln>
+        </p:spPr>
+        <p:style>
+          <a:lnRef idx="1">
+            <a:schemeClr val="accent1"/>
+          </a:lnRef>
+          <a:fillRef idx="3">
+            <a:schemeClr val="accent1"/>
+          </a:fillRef>
+          <a:effectRef idx="2">
+            <a:schemeClr val="accent1"/>
+          </a:effectRef>
+          <a:fontRef idx="minor">
+            <a:schemeClr val="lt1"/>
+          </a:fontRef>
+        </p:style>
+        <p:txBody>
+          <a:bodyPr rtlCol="0" anchor="ctr"/>
+          <a:lstStyle/>
+          <a:p>
+            <a:pPr algn="ctr"/>
+          </a:p>
+        </p:txBody>
+      </p:sp>
+      <p:sp>
+        <p:nvSpPr>
+          <p:cNvPr id="74" name="TextBox 73"/>
+          <p:cNvSpPr txBox="1"/>
+          <p:nvPr/>
+        </p:nvSpPr>
+        <p:spPr>
+          <a:xfrm>
+            <a:off x="731520" y="4754880"/>
+            <a:ext cx="3108960" cy="228600"/>
+          </a:xfrm>
+          <a:prstGeom prst="rect">
+            <a:avLst/>
+          </a:prstGeom>
+          <a:noFill/>
+        </p:spPr>
+        <p:txBody>
+          <a:bodyPr wrap="square"/>
+          <a:lstStyle/>
+          <a:p>
+            <a:pPr algn="l">
+              <a:defRPr sz="1100" b="1">
+                <a:solidFill>
+                  <a:srgbClr val="1D4ED8"/>
+                </a:solidFill>
+                <a:latin typeface="Calibri"/>
+              </a:defRPr>
+            </a:pPr>
+            <a:r>
+              <a:t>Trust-Weighted Scoring</a:t>
+            </a:r>
+          </a:p>
+        </p:txBody>
+      </p:sp>
+      <p:sp>
+        <p:nvSpPr>
+          <p:cNvPr id="75" name="TextBox 74"/>
+          <p:cNvSpPr txBox="1"/>
+          <p:nvPr/>
+        </p:nvSpPr>
+        <p:spPr>
+          <a:xfrm>
+            <a:off x="731520" y="5029200"/>
+            <a:ext cx="3108960" cy="457200"/>
+          </a:xfrm>
+          <a:prstGeom prst="rect">
+            <a:avLst/>
+          </a:prstGeom>
+          <a:noFill/>
+        </p:spPr>
+        <p:txBody>
+          <a:bodyPr wrap="square"/>
+          <a:lstStyle/>
+          <a:p>
+            <a:pPr algn="l">
+              <a:defRPr sz="900" b="0">
+                <a:solidFill>
+                  <a:srgbClr val="374151"/>
+                </a:solidFill>
+                <a:latin typeface="Calibri"/>
+              </a:defRPr>
+            </a:pPr>
+            <a:r>
+              <a:t>35% quality weight captures</a:t>
+            </a:r>
+            <a:br/>
+            <a:r>
+              <a:t>trust erosion from bad matches</a:t>
+            </a:r>
+          </a:p>
+        </p:txBody>
+      </p:sp>
+      <p:sp>
+        <p:nvSpPr>
+          <p:cNvPr id="76" name="Rectangle 75"/>
+          <p:cNvSpPr/>
+          <p:nvPr/>
+        </p:nvSpPr>
+        <p:spPr>
+          <a:xfrm>
+            <a:off x="4343400" y="4572000"/>
+            <a:ext cx="3520440" cy="1005840"/>
+          </a:xfrm>
+          <a:prstGeom prst="rect">
+            <a:avLst/>
+          </a:prstGeom>
+          <a:solidFill>
+            <a:srgbClr val="FFFFFF"/>
+          </a:solidFill>
+          <a:ln>
+            <a:noFill/>
+          </a:ln>
+        </p:spPr>
+        <p:style>
+          <a:lnRef idx="1">
+            <a:schemeClr val="accent1"/>
+          </a:lnRef>
+          <a:fillRef idx="3">
+            <a:schemeClr val="accent1"/>
+          </a:fillRef>
+          <a:effectRef idx="2">
+            <a:schemeClr val="accent1"/>
+          </a:effectRef>
+          <a:fontRef idx="minor">
+            <a:schemeClr val="lt1"/>
+          </a:fontRef>
+        </p:style>
+        <p:txBody>
+          <a:bodyPr rtlCol="0" anchor="ctr"/>
+          <a:lstStyle/>
+          <a:p>
+            <a:pPr algn="ctr"/>
+          </a:p>
+        </p:txBody>
+      </p:sp>
+      <p:sp>
+        <p:nvSpPr>
+          <p:cNvPr id="77" name="Rectangle 76"/>
+          <p:cNvSpPr/>
+          <p:nvPr/>
+        </p:nvSpPr>
+        <p:spPr>
+          <a:xfrm>
+            <a:off x="4343400" y="4572000"/>
+            <a:ext cx="3520440" cy="54864"/>
+          </a:xfrm>
+          <a:prstGeom prst="rect">
+            <a:avLst/>
+          </a:prstGeom>
+          <a:solidFill>
+            <a:srgbClr val="DC2626"/>
+          </a:solidFill>
+          <a:ln>
+            <a:noFill/>
+          </a:ln>
+        </p:spPr>
+        <p:style>
+          <a:lnRef idx="1">
+            <a:schemeClr val="accent1"/>
+          </a:lnRef>
+          <a:fillRef idx="3">
+            <a:schemeClr val="accent1"/>
+          </a:fillRef>
+          <a:effectRef idx="2">
+            <a:schemeClr val="accent1"/>
+          </a:effectRef>
+          <a:fontRef idx="minor">
+            <a:schemeClr val="lt1"/>
+          </a:fontRef>
+        </p:style>
+        <p:txBody>
+          <a:bodyPr rtlCol="0" anchor="ctr"/>
+          <a:lstStyle/>
+          <a:p>
+            <a:pPr algn="ctr"/>
+          </a:p>
+        </p:txBody>
+      </p:sp>
+      <p:sp>
+        <p:nvSpPr>
+          <p:cNvPr id="78" name="TextBox 77"/>
+          <p:cNvSpPr txBox="1"/>
+          <p:nvPr/>
+        </p:nvSpPr>
+        <p:spPr>
+          <a:xfrm>
+            <a:off x="4526280" y="4754880"/>
+            <a:ext cx="3108960" cy="228600"/>
+          </a:xfrm>
+          <a:prstGeom prst="rect">
+            <a:avLst/>
+          </a:prstGeom>
+          <a:noFill/>
+        </p:spPr>
+        <p:txBody>
+          <a:bodyPr wrap="square"/>
+          <a:lstStyle/>
+          <a:p>
+            <a:pPr algn="l">
+              <a:defRPr sz="1100" b="1">
+                <a:solidFill>
+                  <a:srgbClr val="DC2626"/>
+                </a:solidFill>
+                <a:latin typeface="Calibri"/>
+              </a:defRPr>
+            </a:pPr>
+            <a:r>
+              <a:t>Risk Incident Tracking</a:t>
+            </a:r>
+          </a:p>
+        </p:txBody>
+      </p:sp>
+      <p:sp>
+        <p:nvSpPr>
+          <p:cNvPr id="79" name="TextBox 78"/>
+          <p:cNvSpPr txBox="1"/>
+          <p:nvPr/>
+        </p:nvSpPr>
+        <p:spPr>
+          <a:xfrm>
+            <a:off x="4526280" y="5029200"/>
+            <a:ext cx="3108960" cy="457200"/>
+          </a:xfrm>
+          <a:prstGeom prst="rect">
+            <a:avLst/>
+          </a:prstGeom>
+          <a:noFill/>
+        </p:spPr>
+        <p:txBody>
+          <a:bodyPr wrap="square"/>
+          <a:lstStyle/>
+          <a:p>
+            <a:pPr algn="l">
+              <a:defRPr sz="900" b="0">
+                <a:solidFill>
+                  <a:srgbClr val="374151"/>
+                </a:solidFill>
+                <a:latin typeface="Calibri"/>
+              </a:defRPr>
+            </a:pPr>
+            <a:r>
+              <a:t>Regulatory risk events modeled</a:t>
+            </a:r>
+            <a:br/>
+            <a:r>
+              <a:t>per algorithm over 30 days</a:t>
+            </a:r>
+          </a:p>
+        </p:txBody>
+      </p:sp>
+      <p:sp>
+        <p:nvSpPr>
+          <p:cNvPr id="80" name="Rectangle 79"/>
+          <p:cNvSpPr/>
+          <p:nvPr/>
+        </p:nvSpPr>
+        <p:spPr>
+          <a:xfrm>
+            <a:off x="8138160" y="4572000"/>
+            <a:ext cx="3520440" cy="1005840"/>
+          </a:xfrm>
+          <a:prstGeom prst="rect">
+            <a:avLst/>
+          </a:prstGeom>
+          <a:solidFill>
+            <a:srgbClr val="FFFFFF"/>
+          </a:solidFill>
+          <a:ln>
+            <a:noFill/>
+          </a:ln>
+        </p:spPr>
+        <p:style>
+          <a:lnRef idx="1">
+            <a:schemeClr val="accent1"/>
+          </a:lnRef>
+          <a:fillRef idx="3">
+            <a:schemeClr val="accent1"/>
+          </a:fillRef>
+          <a:effectRef idx="2">
+            <a:schemeClr val="accent1"/>
+          </a:effectRef>
+          <a:fontRef idx="minor">
+            <a:schemeClr val="lt1"/>
+          </a:fontRef>
+        </p:style>
+        <p:txBody>
+          <a:bodyPr rtlCol="0" anchor="ctr"/>
+          <a:lstStyle/>
+          <a:p>
+            <a:pPr algn="ctr"/>
+          </a:p>
+        </p:txBody>
+      </p:sp>
+      <p:sp>
+        <p:nvSpPr>
+          <p:cNvPr id="81" name="Rectangle 80"/>
+          <p:cNvSpPr/>
+          <p:nvPr/>
+        </p:nvSpPr>
+        <p:spPr>
+          <a:xfrm>
+            <a:off x="8138160" y="4572000"/>
+            <a:ext cx="3520440" cy="54864"/>
+          </a:xfrm>
+          <a:prstGeom prst="rect">
+            <a:avLst/>
+          </a:prstGeom>
+          <a:solidFill>
+            <a:srgbClr val="16A34A"/>
+          </a:solidFill>
+          <a:ln>
+            <a:noFill/>
+          </a:ln>
+        </p:spPr>
+        <p:style>
+          <a:lnRef idx="1">
+            <a:schemeClr val="accent1"/>
+          </a:lnRef>
+          <a:fillRef idx="3">
+            <a:schemeClr val="accent1"/>
+          </a:fillRef>
+          <a:effectRef idx="2">
+            <a:schemeClr val="accent1"/>
+          </a:effectRef>
+          <a:fontRef idx="minor">
+            <a:schemeClr val="lt1"/>
+          </a:fontRef>
+        </p:style>
+        <p:txBody>
+          <a:bodyPr rtlCol="0" anchor="ctr"/>
+          <a:lstStyle/>
+          <a:p>
+            <a:pPr algn="ctr"/>
+          </a:p>
+        </p:txBody>
+      </p:sp>
+      <p:sp>
+        <p:nvSpPr>
+          <p:cNvPr id="82" name="TextBox 81"/>
+          <p:cNvSpPr txBox="1"/>
+          <p:nvPr/>
+        </p:nvSpPr>
+        <p:spPr>
+          <a:xfrm>
+            <a:off x="8321040" y="4754880"/>
+            <a:ext cx="3108960" cy="228600"/>
+          </a:xfrm>
+          <a:prstGeom prst="rect">
+            <a:avLst/>
+          </a:prstGeom>
+          <a:noFill/>
+        </p:spPr>
+        <p:txBody>
+          <a:bodyPr wrap="square"/>
+          <a:lstStyle/>
+          <a:p>
+            <a:pPr algn="l">
+              <a:defRPr sz="1100" b="1">
+                <a:solidFill>
+                  <a:srgbClr val="16A34A"/>
+                </a:solidFill>
+                <a:latin typeface="Calibri"/>
+              </a:defRPr>
+            </a:pPr>
+            <a:r>
+              <a:t>Lifecycle CPA Analysis</a:t>
+            </a:r>
+          </a:p>
+        </p:txBody>
+      </p:sp>
+      <p:sp>
+        <p:nvSpPr>
+          <p:cNvPr id="83" name="TextBox 82"/>
+          <p:cNvSpPr txBox="1"/>
+          <p:nvPr/>
+        </p:nvSpPr>
+        <p:spPr>
+          <a:xfrm>
+            <a:off x="8321040" y="5029200"/>
+            <a:ext cx="3108960" cy="457200"/>
+          </a:xfrm>
+          <a:prstGeom prst="rect">
+            <a:avLst/>
+          </a:prstGeom>
+          <a:noFill/>
+        </p:spPr>
+        <p:txBody>
+          <a:bodyPr wrap="square"/>
+          <a:lstStyle/>
+          <a:p>
+            <a:pPr algn="l">
+              <a:defRPr sz="900" b="0">
+                <a:solidFill>
+                  <a:srgbClr val="374151"/>
+                </a:solidFill>
+                <a:latin typeface="Calibri"/>
+              </a:defRPr>
+            </a:pPr>
+            <a:r>
+              <a:t>Conversion windows from 14-45d</a:t>
+            </a:r>
+            <a:br/>
+            <a:r>
+              <a:t>by sub-vertical complexity</a:t>
+            </a:r>
+          </a:p>
+        </p:txBody>
+      </p:sp>
+      <p:sp>
+        <p:nvSpPr>
+          <p:cNvPr id="84" name="Rectangle 83"/>
+          <p:cNvSpPr/>
+          <p:nvPr/>
+        </p:nvSpPr>
+        <p:spPr>
+          <a:xfrm>
+            <a:off x="548640" y="5760720"/>
+            <a:ext cx="11064240" cy="777240"/>
+          </a:xfrm>
+          <a:prstGeom prst="rect">
+            <a:avLst/>
+          </a:prstGeom>
+          <a:solidFill>
+            <a:srgbClr val="F5F3FF"/>
+          </a:solidFill>
+          <a:ln>
+            <a:noFill/>
+          </a:ln>
+        </p:spPr>
+        <p:style>
+          <a:lnRef idx="1">
+            <a:schemeClr val="accent1"/>
+          </a:lnRef>
+          <a:fillRef idx="3">
+            <a:schemeClr val="accent1"/>
+          </a:fillRef>
+          <a:effectRef idx="2">
+            <a:schemeClr val="accent1"/>
+          </a:effectRef>
+          <a:fontRef idx="minor">
+            <a:schemeClr val="lt1"/>
+          </a:fontRef>
+        </p:style>
+        <p:txBody>
+          <a:bodyPr rtlCol="0" anchor="ctr"/>
+          <a:lstStyle/>
+          <a:p>
+            <a:pPr algn="ctr"/>
+          </a:p>
+        </p:txBody>
+      </p:sp>
+      <p:sp>
+        <p:nvSpPr>
+          <p:cNvPr id="85" name="Rectangle 84"/>
+          <p:cNvSpPr/>
+          <p:nvPr/>
+        </p:nvSpPr>
+        <p:spPr>
+          <a:xfrm>
+            <a:off x="548640" y="5760720"/>
+            <a:ext cx="54864" cy="777240"/>
+          </a:xfrm>
+          <a:prstGeom prst="rect">
+            <a:avLst/>
+          </a:prstGeom>
+          <a:solidFill>
+            <a:srgbClr val="7C3AED"/>
+          </a:solidFill>
+          <a:ln>
+            <a:noFill/>
+          </a:ln>
+        </p:spPr>
+        <p:style>
+          <a:lnRef idx="1">
+            <a:schemeClr val="accent1"/>
+          </a:lnRef>
+          <a:fillRef idx="3">
+            <a:schemeClr val="accent1"/>
+          </a:fillRef>
+          <a:effectRef idx="2">
+            <a:schemeClr val="accent1"/>
+          </a:effectRef>
+          <a:fontRef idx="minor">
+            <a:schemeClr val="lt1"/>
+          </a:fontRef>
+        </p:style>
+        <p:txBody>
+          <a:bodyPr rtlCol="0" anchor="ctr"/>
+          <a:lstStyle/>
+          <a:p>
+            <a:pPr algn="ctr"/>
+          </a:p>
+        </p:txBody>
+      </p:sp>
+      <p:sp>
+        <p:nvSpPr>
+          <p:cNvPr id="86" name="TextBox 85"/>
+          <p:cNvSpPr txBox="1"/>
+          <p:nvPr/>
+        </p:nvSpPr>
+        <p:spPr>
+          <a:xfrm>
+            <a:off x="777240" y="5852160"/>
+            <a:ext cx="10515600" cy="548640"/>
+          </a:xfrm>
+          <a:prstGeom prst="rect">
+            <a:avLst/>
+          </a:prstGeom>
+          <a:noFill/>
+        </p:spPr>
+        <p:txBody>
+          <a:bodyPr wrap="square"/>
+          <a:lstStyle/>
+          <a:p>
+            <a:pPr algn="l">
+              <a:defRPr sz="1000" b="0">
+                <a:solidFill>
+                  <a:srgbClr val="4C1D95"/>
+                </a:solidFill>
+                <a:latin typeface="Calibri"/>
+              </a:defRPr>
+            </a:pPr>
+            <a:r>
+              <a:t>In financial services, the revenue-maximizing algorithm (DLRM) is NOT the optimal choice. The Risk-Adjusted Ranker wins by maintaining 87% user trust with only 3 risk incidents — critical in a domain where a single bad ad recommendation can destroy months of trust-building. This demonstrates why multi-objective optimization with domain-specific weights outperforms raw CTR/revenue optimization.</a:t>
+            </a:r>
+          </a:p>
+        </p:txBody>
+      </p:sp>
+    </p:spTree>
+  </p:cSld>
+  <p:clrMapOvr>
+    <a:masterClrMapping/>
+  </p:clrMapOvr>
+</p:sld>
+</file>
+
+<file path=ppt/slides/slide12.xml><?xml version="1.0" encoding="utf-8"?>
+<p:sld xmlns:a="http://schemas.openxmlformats.org/drawingml/2006/main" xmlns:p="http://schemas.openxmlformats.org/presentationml/2006/main" xmlns:r="http://schemas.openxmlformats.org/officeDocument/2006/relationships">
+  <p:cSld>
+    <p:spTree>
+      <p:nvGrpSpPr>
+        <p:cNvPr id="1" name=""/>
+        <p:cNvGrpSpPr/>
+        <p:nvPr/>
+      </p:nvGrpSpPr>
+      <p:grpSpPr/>
+      <p:sp>
+        <p:nvSpPr>
           <p:cNvPr id="2" name="Rectangle 1"/>
           <p:cNvSpPr/>
           <p:nvPr/>
@@ -6796,7 +9923,7 @@
               </a:defRPr>
             </a:pPr>
             <a:r>
-              <a:t>9</a:t>
+              <a:t>10</a:t>
             </a:r>
           </a:p>
         </p:txBody>

</xml_diff>